<commit_message>
Exposicion Bank: segundo camino de balanceo por sobremuestreo, education ordinal sin escalar y correcciones de la revision
</commit_message>
<xml_diff>
--- a/Exposicion Bank/exposicion_bank.pptx
+++ b/Exposicion Bank/exposicion_bank.pptx
@@ -19,6 +19,7 @@
     <p:sldId id="267" r:id="rId18"/>
     <p:sldId id="268" r:id="rId19"/>
     <p:sldId id="269" r:id="rId20"/>
+    <p:sldId id="270" r:id="rId21"/>
   </p:sldIdLst>
   <p:sldSz cx="12191695" cy="6858000" type="screen4x3"/>
   <p:notesSz cx="6858000" cy="9144000"/>
@@ -3412,7 +3413,7 @@
                         </a:defRPr>
                       </a:pPr>
                       <a:r>
-                        <a:t>binaria yes/no</a:t>
+                        <a:t>binaria</a:t>
                       </a:r>
                     </a:p>
                   </a:txBody>
@@ -3429,7 +3430,7 @@
                         </a:defRPr>
                       </a:pPr>
                       <a:r>
-                        <a:t>default, housing, loan</a:t>
+                        <a:t>default, housing, loan, contactado_antes</a:t>
                       </a:r>
                     </a:p>
                   </a:txBody>
@@ -3463,7 +3464,7 @@
                         </a:defRPr>
                       </a:pPr>
                       <a:r>
-                        <a:t>3</a:t>
+                        <a:t>4</a:t>
                       </a:r>
                     </a:p>
                   </a:txBody>
@@ -3849,7 +3850,7 @@
                         </a:defRPr>
                       </a:pPr>
                       <a:r>
-                        <a:t>age, balance, campaign, pdays, previous, dia_anio, contactado_antes</a:t>
+                        <a:t>age, balance, campaign, pdays, previous, dia_anio</a:t>
                       </a:r>
                     </a:p>
                   </a:txBody>
@@ -3883,7 +3884,7 @@
                         </a:defRPr>
                       </a:pPr>
                       <a:r>
-                        <a:t>7</a:t>
+                        <a:t>6</a:t>
                       </a:r>
                     </a:p>
                   </a:txBody>
@@ -3925,7 +3926,7 @@
               </a:defRPr>
             </a:pPr>
             <a:r>
-              <a:t>• poutcome_unknown se elimina porque equivale a previous igual a cero</a:t>
+              <a:t>• poutcome_unknown se elimina por redundancia, se deduce de las otras tres indicadoras y marca a los nunca contactados, que ya identifica contactado_antes</a:t>
             </a:r>
           </a:p>
           <a:p>
@@ -4005,7 +4006,7 @@
               </a:defRPr>
             </a:pPr>
             <a:r>
-              <a:t>Solo sobre las siete columnas numéricas, las indicadoras se quedan en 0 y 1</a:t>
+              <a:t>Sobre age, balance, campaign, pdays, previous y dia_anio. Las indicadoras, contactado_antes y education se quedan como están</a:t>
             </a:r>
           </a:p>
         </p:txBody>
@@ -4070,7 +4071,7 @@
         <p:spPr>
           <a:xfrm>
             <a:off x="457200" y="1325880"/>
-            <a:ext cx="7498079" cy="5090854"/>
+            <a:ext cx="7498079" cy="4930037"/>
           </a:xfrm>
           <a:prstGeom prst="rect">
             <a:avLst/>
@@ -4134,7 +4135,7 @@
               </a:defRPr>
             </a:pPr>
             <a:r>
-              <a:t>• pdays se ve rara porque el 82 % vale 240 y el resto queda por debajo</a:t>
+              <a:t>• pdays se ve concentrada porque el 90 % de las filas vale 240 y el resto queda por debajo</a:t>
             </a:r>
           </a:p>
           <a:p>
@@ -4214,7 +4215,7 @@
               </a:defRPr>
             </a:pPr>
             <a:r>
-              <a:t>T3. Balanceo</a:t>
+              <a:t>T3. Balanceo por dos caminos</a:t>
             </a:r>
           </a:p>
           <a:p>
@@ -4227,7 +4228,7 @@
               </a:defRPr>
             </a:pPr>
             <a:r>
-              <a:t>Submuestreo aleatorio de la clase no</a:t>
+              <a:t>Submuestreo de la clase no (T3_1) y sobremuestreo sintético de la clase sí (T3_2)</a:t>
             </a:r>
           </a:p>
         </p:txBody>
@@ -4292,7 +4293,7 @@
         <p:spPr>
           <a:xfrm>
             <a:off x="457200" y="1325880"/>
-            <a:ext cx="6766560" cy="4426889"/>
+            <a:ext cx="6766560" cy="4435906"/>
           </a:xfrm>
           <a:prstGeom prst="rect">
             <a:avLst/>
@@ -4330,7 +4331,7 @@
               </a:defRPr>
             </a:pPr>
             <a:r>
-              <a:t>• Se toman al azar 5 255 no para igualar a los 5 255 sí</a:t>
+              <a:t>• T3_1. Se toman al azar 5 255 no para igualar a los 5 255 sí, quedan 10 510 filas</a:t>
             </a:r>
           </a:p>
           <a:p>
@@ -4343,7 +4344,7 @@
               </a:defRPr>
             </a:pPr>
             <a:r>
-              <a:t>• Quedan 10 510 filas, suficientes para entrenar</a:t>
+              <a:t>• T3_2. Se crean 34 413 sí sintéticos entre cada positivo y uno de sus cinco vecinos más cercanos, quedan 79 336 filas</a:t>
             </a:r>
           </a:p>
           <a:p>
@@ -4356,7 +4357,7 @@
               </a:defRPr>
             </a:pPr>
             <a:r>
-              <a:t>• No se sobremuestrea porque inventar 34 000 filas sintéticas hace lento el entrenamiento y no agrega información real</a:t>
+              <a:t>• En T3_2 las indicadoras se redondean para que sigan valiendo 0 o 1 y education para que siga en 1, 2 o 3</a:t>
             </a:r>
           </a:p>
           <a:p>
@@ -4369,7 +4370,7 @@
               </a:defRPr>
             </a:pPr>
             <a:r>
-              <a:t>• Semilla fija para que la muestra sea reproducible</a:t>
+              <a:t>• No se duplican filas porque la copia y su original caen en particiones distintas y la prueba deja de ser independiente</a:t>
             </a:r>
           </a:p>
           <a:p>
@@ -4382,7 +4383,20 @@
               </a:defRPr>
             </a:pPr>
             <a:r>
-              <a:t>• Se guarda T3z desde la estandarizada y T3n desde la normalizada, con las mismas filas</a:t>
+              <a:t>• Con los sintéticos el riesgo baja pero no desaparece, la comparación entre T3_1 y T3_2 debe leerse con esa reserva</a:t>
+            </a:r>
+          </a:p>
+          <a:p>
+            <a:pPr>
+              <a:spcAft>
+                <a:spcPts val="600"/>
+              </a:spcAft>
+              <a:defRPr sz="1500">
+                <a:latin typeface="Calibri"/>
+              </a:defRPr>
+            </a:pPr>
+            <a:r>
+              <a:t>• Semilla fija en los dos caminos y las mismas filas en la versión z y en la versión n</a:t>
             </a:r>
           </a:p>
         </p:txBody>
@@ -4436,7 +4450,7 @@
               </a:defRPr>
             </a:pPr>
             <a:r>
-              <a:t>Resumen de las versiones del dato</a:t>
+              <a:t>Categóricas y numéricas mezcladas</a:t>
             </a:r>
           </a:p>
           <a:p>
@@ -4449,7 +4463,7 @@
               </a:defRPr>
             </a:pPr>
             <a:r>
-              <a:t>Tablas que quedan en bank_pasos.mat</a:t>
+              <a:t>Efecto sobre la distancia en KNN y sobre el sobremuestreo</a:t>
             </a:r>
           </a:p>
         </p:txBody>
@@ -4497,566 +4511,16 @@
           </a:p>
         </p:txBody>
       </p:sp>
-      <p:graphicFrame>
-        <p:nvGraphicFramePr>
-          <p:cNvPr id="4" name="Table 3"/>
-          <p:cNvGraphicFramePr>
-            <a:graphicFrameLocks noGrp="1"/>
-          </p:cNvGraphicFramePr>
-          <p:nvPr/>
-        </p:nvGraphicFramePr>
-        <p:xfrm>
-          <a:off x="457200" y="1371600"/>
-          <a:ext cx="11247120" cy="2377440"/>
-        </p:xfrm>
-        <a:graphic>
-          <a:graphicData uri="http://schemas.openxmlformats.org/drawingml/2006/table">
-            <a:tbl>
-              <a:tblPr firstRow="1" bandRow="1">
-                <a:tableStyleId>{5C22544A-7EE6-4342-B048-85BDC9FD1C3A}</a:tableStyleId>
-              </a:tblPr>
-              <a:tblGrid>
-                <a:gridCol w="1874520"/>
-                <a:gridCol w="1874520"/>
-                <a:gridCol w="1874520"/>
-                <a:gridCol w="1874520"/>
-                <a:gridCol w="1874520"/>
-                <a:gridCol w="1874520"/>
-              </a:tblGrid>
-              <a:tr h="475488">
-                <a:tc>
-                  <a:txBody>
-                    <a:bodyPr/>
-                    <a:lstStyle/>
-                    <a:p>
-                      <a:pPr>
-                        <a:defRPr sz="1400" b="1">
-                          <a:latin typeface="Calibri"/>
-                        </a:defRPr>
-                      </a:pPr>
-                      <a:r>
-                        <a:t>Paso</a:t>
-                      </a:r>
-                    </a:p>
-                  </a:txBody>
-                  <a:tcPr/>
-                </a:tc>
-                <a:tc>
-                  <a:txBody>
-                    <a:bodyPr/>
-                    <a:lstStyle/>
-                    <a:p>
-                      <a:pPr>
-                        <a:defRPr sz="1400" b="1">
-                          <a:latin typeface="Calibri"/>
-                        </a:defRPr>
-                      </a:pPr>
-                      <a:r>
-                        <a:t>Filas</a:t>
-                      </a:r>
-                    </a:p>
-                  </a:txBody>
-                  <a:tcPr/>
-                </a:tc>
-                <a:tc>
-                  <a:txBody>
-                    <a:bodyPr/>
-                    <a:lstStyle/>
-                    <a:p>
-                      <a:pPr>
-                        <a:defRPr sz="1400" b="1">
-                          <a:latin typeface="Calibri"/>
-                        </a:defRPr>
-                      </a:pPr>
-                      <a:r>
-                        <a:t>Columnas de entrada</a:t>
-                      </a:r>
-                    </a:p>
-                  </a:txBody>
-                  <a:tcPr/>
-                </a:tc>
-                <a:tc>
-                  <a:txBody>
-                    <a:bodyPr/>
-                    <a:lstStyle/>
-                    <a:p>
-                      <a:pPr>
-                        <a:defRPr sz="1400" b="1">
-                          <a:latin typeface="Calibri"/>
-                        </a:defRPr>
-                      </a:pPr>
-                      <a:r>
-                        <a:t>No</a:t>
-                      </a:r>
-                    </a:p>
-                  </a:txBody>
-                  <a:tcPr/>
-                </a:tc>
-                <a:tc>
-                  <a:txBody>
-                    <a:bodyPr/>
-                    <a:lstStyle/>
-                    <a:p>
-                      <a:pPr>
-                        <a:defRPr sz="1400" b="1">
-                          <a:latin typeface="Calibri"/>
-                        </a:defRPr>
-                      </a:pPr>
-                      <a:r>
-                        <a:t>Sí</a:t>
-                      </a:r>
-                    </a:p>
-                  </a:txBody>
-                  <a:tcPr/>
-                </a:tc>
-                <a:tc>
-                  <a:txBody>
-                    <a:bodyPr/>
-                    <a:lstStyle/>
-                    <a:p>
-                      <a:pPr>
-                        <a:defRPr sz="1400" b="1">
-                          <a:latin typeface="Calibri"/>
-                        </a:defRPr>
-                      </a:pPr>
-                      <a:r>
-                        <a:t>Qué cambió</a:t>
-                      </a:r>
-                    </a:p>
-                  </a:txBody>
-                  <a:tcPr/>
-                </a:tc>
-              </a:tr>
-              <a:tr h="475488">
-                <a:tc>
-                  <a:txBody>
-                    <a:bodyPr/>
-                    <a:lstStyle/>
-                    <a:p>
-                      <a:pPr>
-                        <a:defRPr sz="1400">
-                          <a:latin typeface="Calibri"/>
-                        </a:defRPr>
-                      </a:pPr>
-                      <a:r>
-                        <a:t>T0</a:t>
-                      </a:r>
-                    </a:p>
-                  </a:txBody>
-                  <a:tcPr/>
-                </a:tc>
-                <a:tc>
-                  <a:txBody>
-                    <a:bodyPr/>
-                    <a:lstStyle/>
-                    <a:p>
-                      <a:pPr>
-                        <a:defRPr sz="1400">
-                          <a:latin typeface="Calibri"/>
-                        </a:defRPr>
-                      </a:pPr>
-                      <a:r>
-                        <a:t>45 211</a:t>
-                      </a:r>
-                    </a:p>
-                  </a:txBody>
-                  <a:tcPr/>
-                </a:tc>
-                <a:tc>
-                  <a:txBody>
-                    <a:bodyPr/>
-                    <a:lstStyle/>
-                    <a:p>
-                      <a:pPr>
-                        <a:defRPr sz="1400">
-                          <a:latin typeface="Calibri"/>
-                        </a:defRPr>
-                      </a:pPr>
-                      <a:r>
-                        <a:t>16</a:t>
-                      </a:r>
-                    </a:p>
-                  </a:txBody>
-                  <a:tcPr/>
-                </a:tc>
-                <a:tc>
-                  <a:txBody>
-                    <a:bodyPr/>
-                    <a:lstStyle/>
-                    <a:p>
-                      <a:pPr>
-                        <a:defRPr sz="1400">
-                          <a:latin typeface="Calibri"/>
-                        </a:defRPr>
-                      </a:pPr>
-                      <a:r>
-                        <a:t>39 922</a:t>
-                      </a:r>
-                    </a:p>
-                  </a:txBody>
-                  <a:tcPr/>
-                </a:tc>
-                <a:tc>
-                  <a:txBody>
-                    <a:bodyPr/>
-                    <a:lstStyle/>
-                    <a:p>
-                      <a:pPr>
-                        <a:defRPr sz="1400">
-                          <a:latin typeface="Calibri"/>
-                        </a:defRPr>
-                      </a:pPr>
-                      <a:r>
-                        <a:t>5 289</a:t>
-                      </a:r>
-                    </a:p>
-                  </a:txBody>
-                  <a:tcPr/>
-                </a:tc>
-                <a:tc>
-                  <a:txBody>
-                    <a:bodyPr/>
-                    <a:lstStyle/>
-                    <a:p>
-                      <a:pPr>
-                        <a:defRPr sz="1400">
-                          <a:latin typeface="Calibri"/>
-                        </a:defRPr>
-                      </a:pPr>
-                      <a:r>
-                        <a:t>dato crudo</a:t>
-                      </a:r>
-                    </a:p>
-                  </a:txBody>
-                  <a:tcPr/>
-                </a:tc>
-              </a:tr>
-              <a:tr h="475488">
-                <a:tc>
-                  <a:txBody>
-                    <a:bodyPr/>
-                    <a:lstStyle/>
-                    <a:p>
-                      <a:pPr>
-                        <a:defRPr sz="1400">
-                          <a:latin typeface="Calibri"/>
-                        </a:defRPr>
-                      </a:pPr>
-                      <a:r>
-                        <a:t>T1</a:t>
-                      </a:r>
-                    </a:p>
-                  </a:txBody>
-                  <a:tcPr/>
-                </a:tc>
-                <a:tc>
-                  <a:txBody>
-                    <a:bodyPr/>
-                    <a:lstStyle/>
-                    <a:p>
-                      <a:pPr>
-                        <a:defRPr sz="1400">
-                          <a:latin typeface="Calibri"/>
-                        </a:defRPr>
-                      </a:pPr>
-                      <a:r>
-                        <a:t>44 923</a:t>
-                      </a:r>
-                    </a:p>
-                  </a:txBody>
-                  <a:tcPr/>
-                </a:tc>
-                <a:tc>
-                  <a:txBody>
-                    <a:bodyPr/>
-                    <a:lstStyle/>
-                    <a:p>
-                      <a:pPr>
-                        <a:defRPr sz="1400">
-                          <a:latin typeface="Calibri"/>
-                        </a:defRPr>
-                      </a:pPr>
-                      <a:r>
-                        <a:t>15</a:t>
-                      </a:r>
-                    </a:p>
-                  </a:txBody>
-                  <a:tcPr/>
-                </a:tc>
-                <a:tc>
-                  <a:txBody>
-                    <a:bodyPr/>
-                    <a:lstStyle/>
-                    <a:p>
-                      <a:pPr>
-                        <a:defRPr sz="1400">
-                          <a:latin typeface="Calibri"/>
-                        </a:defRPr>
-                      </a:pPr>
-                      <a:r>
-                        <a:t>39 668</a:t>
-                      </a:r>
-                    </a:p>
-                  </a:txBody>
-                  <a:tcPr/>
-                </a:tc>
-                <a:tc>
-                  <a:txBody>
-                    <a:bodyPr/>
-                    <a:lstStyle/>
-                    <a:p>
-                      <a:pPr>
-                        <a:defRPr sz="1400">
-                          <a:latin typeface="Calibri"/>
-                        </a:defRPr>
-                      </a:pPr>
-                      <a:r>
-                        <a:t>5 255</a:t>
-                      </a:r>
-                    </a:p>
-                  </a:txBody>
-                  <a:tcPr/>
-                </a:tc>
-                <a:tc>
-                  <a:txBody>
-                    <a:bodyPr/>
-                    <a:lstStyle/>
-                    <a:p>
-                      <a:pPr>
-                        <a:defRPr sz="1400">
-                          <a:latin typeface="Calibri"/>
-                        </a:defRPr>
-                      </a:pPr>
-                      <a:r>
-                        <a:t>sin duration, dia_anio, education ordinal, pdays con umbral, atípicos recortados</a:t>
-                      </a:r>
-                    </a:p>
-                  </a:txBody>
-                  <a:tcPr/>
-                </a:tc>
-              </a:tr>
-              <a:tr h="475488">
-                <a:tc>
-                  <a:txBody>
-                    <a:bodyPr/>
-                    <a:lstStyle/>
-                    <a:p>
-                      <a:pPr>
-                        <a:defRPr sz="1400">
-                          <a:latin typeface="Calibri"/>
-                        </a:defRPr>
-                      </a:pPr>
-                      <a:r>
-                        <a:t>T2z y T2n</a:t>
-                      </a:r>
-                    </a:p>
-                  </a:txBody>
-                  <a:tcPr/>
-                </a:tc>
-                <a:tc>
-                  <a:txBody>
-                    <a:bodyPr/>
-                    <a:lstStyle/>
-                    <a:p>
-                      <a:pPr>
-                        <a:defRPr sz="1400">
-                          <a:latin typeface="Calibri"/>
-                        </a:defRPr>
-                      </a:pPr>
-                      <a:r>
-                        <a:t>44 923</a:t>
-                      </a:r>
-                    </a:p>
-                  </a:txBody>
-                  <a:tcPr/>
-                </a:tc>
-                <a:tc>
-                  <a:txBody>
-                    <a:bodyPr/>
-                    <a:lstStyle/>
-                    <a:p>
-                      <a:pPr>
-                        <a:defRPr sz="1400">
-                          <a:latin typeface="Calibri"/>
-                        </a:defRPr>
-                      </a:pPr>
-                      <a:r>
-                        <a:t>31</a:t>
-                      </a:r>
-                    </a:p>
-                  </a:txBody>
-                  <a:tcPr/>
-                </a:tc>
-                <a:tc>
-                  <a:txBody>
-                    <a:bodyPr/>
-                    <a:lstStyle/>
-                    <a:p>
-                      <a:pPr>
-                        <a:defRPr sz="1400">
-                          <a:latin typeface="Calibri"/>
-                        </a:defRPr>
-                      </a:pPr>
-                      <a:r>
-                        <a:t>39 668</a:t>
-                      </a:r>
-                    </a:p>
-                  </a:txBody>
-                  <a:tcPr/>
-                </a:tc>
-                <a:tc>
-                  <a:txBody>
-                    <a:bodyPr/>
-                    <a:lstStyle/>
-                    <a:p>
-                      <a:pPr>
-                        <a:defRPr sz="1400">
-                          <a:latin typeface="Calibri"/>
-                        </a:defRPr>
-                      </a:pPr>
-                      <a:r>
-                        <a:t>5 255</a:t>
-                      </a:r>
-                    </a:p>
-                  </a:txBody>
-                  <a:tcPr/>
-                </a:tc>
-                <a:tc>
-                  <a:txBody>
-                    <a:bodyPr/>
-                    <a:lstStyle/>
-                    <a:p>
-                      <a:pPr>
-                        <a:defRPr sz="1400">
-                          <a:latin typeface="Calibri"/>
-                        </a:defRPr>
-                      </a:pPr>
-                      <a:r>
-                        <a:t>one hot, binarias en 0 y 1, z score o rango 0 a 1</a:t>
-                      </a:r>
-                    </a:p>
-                  </a:txBody>
-                  <a:tcPr/>
-                </a:tc>
-              </a:tr>
-              <a:tr h="475488">
-                <a:tc>
-                  <a:txBody>
-                    <a:bodyPr/>
-                    <a:lstStyle/>
-                    <a:p>
-                      <a:pPr>
-                        <a:defRPr sz="1400">
-                          <a:latin typeface="Calibri"/>
-                        </a:defRPr>
-                      </a:pPr>
-                      <a:r>
-                        <a:t>T3z y T3n</a:t>
-                      </a:r>
-                    </a:p>
-                  </a:txBody>
-                  <a:tcPr/>
-                </a:tc>
-                <a:tc>
-                  <a:txBody>
-                    <a:bodyPr/>
-                    <a:lstStyle/>
-                    <a:p>
-                      <a:pPr>
-                        <a:defRPr sz="1400">
-                          <a:latin typeface="Calibri"/>
-                        </a:defRPr>
-                      </a:pPr>
-                      <a:r>
-                        <a:t>10 510</a:t>
-                      </a:r>
-                    </a:p>
-                  </a:txBody>
-                  <a:tcPr/>
-                </a:tc>
-                <a:tc>
-                  <a:txBody>
-                    <a:bodyPr/>
-                    <a:lstStyle/>
-                    <a:p>
-                      <a:pPr>
-                        <a:defRPr sz="1400">
-                          <a:latin typeface="Calibri"/>
-                        </a:defRPr>
-                      </a:pPr>
-                      <a:r>
-                        <a:t>31</a:t>
-                      </a:r>
-                    </a:p>
-                  </a:txBody>
-                  <a:tcPr/>
-                </a:tc>
-                <a:tc>
-                  <a:txBody>
-                    <a:bodyPr/>
-                    <a:lstStyle/>
-                    <a:p>
-                      <a:pPr>
-                        <a:defRPr sz="1400">
-                          <a:latin typeface="Calibri"/>
-                        </a:defRPr>
-                      </a:pPr>
-                      <a:r>
-                        <a:t>5 255</a:t>
-                      </a:r>
-                    </a:p>
-                  </a:txBody>
-                  <a:tcPr/>
-                </a:tc>
-                <a:tc>
-                  <a:txBody>
-                    <a:bodyPr/>
-                    <a:lstStyle/>
-                    <a:p>
-                      <a:pPr>
-                        <a:defRPr sz="1400">
-                          <a:latin typeface="Calibri"/>
-                        </a:defRPr>
-                      </a:pPr>
-                      <a:r>
-                        <a:t>5 255</a:t>
-                      </a:r>
-                    </a:p>
-                  </a:txBody>
-                  <a:tcPr/>
-                </a:tc>
-                <a:tc>
-                  <a:txBody>
-                    <a:bodyPr/>
-                    <a:lstStyle/>
-                    <a:p>
-                      <a:pPr>
-                        <a:defRPr sz="1400">
-                          <a:latin typeface="Calibri"/>
-                        </a:defRPr>
-                      </a:pPr>
-                      <a:r>
-                        <a:t>submuestreo de la clase no</a:t>
-                      </a:r>
-                    </a:p>
-                  </a:txBody>
-                  <a:tcPr/>
-                </a:tc>
-              </a:tr>
-            </a:tbl>
-          </a:graphicData>
-        </a:graphic>
-      </p:graphicFrame>
-      <p:sp>
-        <p:nvSpPr>
-          <p:cNvPr id="5" name="TextBox 4"/>
+      <p:sp>
+        <p:nvSpPr>
+          <p:cNvPr id="4" name="TextBox 3"/>
           <p:cNvSpPr txBox="1"/>
           <p:nvPr/>
         </p:nvSpPr>
         <p:spPr>
           <a:xfrm>
-            <a:off x="640080" y="4023360"/>
-            <a:ext cx="10972800" cy="2011680"/>
+            <a:off x="640080" y="1463040"/>
+            <a:ext cx="10972800" cy="5029200"/>
           </a:xfrm>
           <a:prstGeom prst="rect">
             <a:avLst/>
@@ -5073,12 +4537,12 @@
               <a:spcAft>
                 <a:spcPts val="600"/>
               </a:spcAft>
-              <a:defRPr sz="1600">
-                <a:latin typeface="Calibri"/>
-              </a:defRPr>
-            </a:pPr>
-            <a:r>
-              <a:t>• Un solo live script, procesar_bank.mlx, genera las cuatro versiones y las figuras</a:t>
+              <a:defRPr sz="1700">
+                <a:latin typeface="Calibri"/>
+              </a:defRPr>
+            </a:pPr>
+            <a:r>
+              <a:t>• Tras T2 todo es numérico, las one hot y las binarias valen 0 o 1, education va de 1 a 3 y las seis numéricas están en z score o en rango 0 a 1</a:t>
             </a:r>
           </a:p>
           <a:p>
@@ -5086,12 +4550,12 @@
               <a:spcAft>
                 <a:spcPts val="600"/>
               </a:spcAft>
-              <a:defRPr sz="1600">
-                <a:latin typeface="Calibri"/>
-              </a:defRPr>
-            </a:pPr>
-            <a:r>
-              <a:t>• Cada tabla lleva la clase y como última columna</a:t>
+              <a:defRPr sz="1700">
+                <a:latin typeface="Calibri"/>
+              </a:defRPr>
+            </a:pPr>
+            <a:r>
+              <a:t>• Dos clientes con distinto oficio difieren en dos columnas one hot, así que la distancia euclídea suma un salto fijo por cada categórica distinta</a:t>
             </a:r>
           </a:p>
           <a:p>
@@ -5099,12 +4563,51 @@
               <a:spcAft>
                 <a:spcPts val="600"/>
               </a:spcAft>
-              <a:defRPr sz="1600">
-                <a:latin typeface="Calibri"/>
-              </a:defRPr>
-            </a:pPr>
-            <a:r>
-              <a:t>• Ninguna versión modifica la clase ni elimina positivos, salvo las 34 filas con job unknown</a:t>
+              <a:defRPr sz="1700">
+                <a:latin typeface="Calibri"/>
+              </a:defRPr>
+            </a:pPr>
+            <a:r>
+              <a:t>• Con z score las numéricas pesan más que las indicadoras, con rango 0 a 1 quedan en la misma escala, por eso se comparan las versiones z y n</a:t>
+            </a:r>
+          </a:p>
+          <a:p>
+            <a:pPr>
+              <a:spcAft>
+                <a:spcPts val="600"/>
+              </a:spcAft>
+              <a:defRPr sz="1700">
+                <a:latin typeface="Calibri"/>
+              </a:defRPr>
+            </a:pPr>
+            <a:r>
+              <a:t>• KNN sirve, pero conviene la distancia euclídea sobre la versión n, o la distancia de Manhattan, que trata cada columna por igual</a:t>
+            </a:r>
+          </a:p>
+          <a:p>
+            <a:pPr>
+              <a:spcAft>
+                <a:spcPts val="600"/>
+              </a:spcAft>
+              <a:defRPr sz="1700">
+                <a:latin typeface="Calibri"/>
+              </a:defRPr>
+            </a:pPr>
+            <a:r>
+              <a:t>• Los árboles y los modelos de conjunto no dependen de la escala y manejan las indicadoras sin problema</a:t>
+            </a:r>
+          </a:p>
+          <a:p>
+            <a:pPr>
+              <a:spcAft>
+                <a:spcPts val="600"/>
+              </a:spcAft>
+              <a:defRPr sz="1700">
+                <a:latin typeface="Calibri"/>
+              </a:defRPr>
+            </a:pPr>
+            <a:r>
+              <a:t>• En T3_2 se redondean las indicadoras y education para no crear clientes con valores intermedios en oficio, estado civil o nivel educativo, que no tienen interpretación</a:t>
             </a:r>
           </a:p>
         </p:txBody>
@@ -5158,7 +4661,7 @@
               </a:defRPr>
             </a:pPr>
             <a:r>
-              <a:t>Siguiente paso. Herramienta de clasificación</a:t>
+              <a:t>Resumen de las versiones del dato</a:t>
             </a:r>
           </a:p>
           <a:p>
@@ -5171,7 +4674,7 @@
               </a:defRPr>
             </a:pPr>
             <a:r>
-              <a:t>Qué se va a comparar en Classification Learner</a:t>
+              <a:t>Tablas que quedan en bank_pasos.mat</a:t>
             </a:r>
           </a:p>
         </p:txBody>
@@ -5219,16 +4722,670 @@
           </a:p>
         </p:txBody>
       </p:sp>
-      <p:sp>
-        <p:nvSpPr>
-          <p:cNvPr id="4" name="TextBox 3"/>
+      <p:graphicFrame>
+        <p:nvGraphicFramePr>
+          <p:cNvPr id="4" name="Table 3"/>
+          <p:cNvGraphicFramePr>
+            <a:graphicFrameLocks noGrp="1"/>
+          </p:cNvGraphicFramePr>
+          <p:nvPr/>
+        </p:nvGraphicFramePr>
+        <p:xfrm>
+          <a:off x="457200" y="1371600"/>
+          <a:ext cx="11247120" cy="2743200"/>
+        </p:xfrm>
+        <a:graphic>
+          <a:graphicData uri="http://schemas.openxmlformats.org/drawingml/2006/table">
+            <a:tbl>
+              <a:tblPr firstRow="1" bandRow="1">
+                <a:tableStyleId>{5C22544A-7EE6-4342-B048-85BDC9FD1C3A}</a:tableStyleId>
+              </a:tblPr>
+              <a:tblGrid>
+                <a:gridCol w="1874520"/>
+                <a:gridCol w="1874520"/>
+                <a:gridCol w="1874520"/>
+                <a:gridCol w="1874520"/>
+                <a:gridCol w="1874520"/>
+                <a:gridCol w="1874520"/>
+              </a:tblGrid>
+              <a:tr h="457200">
+                <a:tc>
+                  <a:txBody>
+                    <a:bodyPr/>
+                    <a:lstStyle/>
+                    <a:p>
+                      <a:pPr>
+                        <a:defRPr sz="1400" b="1">
+                          <a:latin typeface="Calibri"/>
+                        </a:defRPr>
+                      </a:pPr>
+                      <a:r>
+                        <a:t>Paso</a:t>
+                      </a:r>
+                    </a:p>
+                  </a:txBody>
+                  <a:tcPr/>
+                </a:tc>
+                <a:tc>
+                  <a:txBody>
+                    <a:bodyPr/>
+                    <a:lstStyle/>
+                    <a:p>
+                      <a:pPr>
+                        <a:defRPr sz="1400" b="1">
+                          <a:latin typeface="Calibri"/>
+                        </a:defRPr>
+                      </a:pPr>
+                      <a:r>
+                        <a:t>Filas</a:t>
+                      </a:r>
+                    </a:p>
+                  </a:txBody>
+                  <a:tcPr/>
+                </a:tc>
+                <a:tc>
+                  <a:txBody>
+                    <a:bodyPr/>
+                    <a:lstStyle/>
+                    <a:p>
+                      <a:pPr>
+                        <a:defRPr sz="1400" b="1">
+                          <a:latin typeface="Calibri"/>
+                        </a:defRPr>
+                      </a:pPr>
+                      <a:r>
+                        <a:t>Columnas de entrada</a:t>
+                      </a:r>
+                    </a:p>
+                  </a:txBody>
+                  <a:tcPr/>
+                </a:tc>
+                <a:tc>
+                  <a:txBody>
+                    <a:bodyPr/>
+                    <a:lstStyle/>
+                    <a:p>
+                      <a:pPr>
+                        <a:defRPr sz="1400" b="1">
+                          <a:latin typeface="Calibri"/>
+                        </a:defRPr>
+                      </a:pPr>
+                      <a:r>
+                        <a:t>No</a:t>
+                      </a:r>
+                    </a:p>
+                  </a:txBody>
+                  <a:tcPr/>
+                </a:tc>
+                <a:tc>
+                  <a:txBody>
+                    <a:bodyPr/>
+                    <a:lstStyle/>
+                    <a:p>
+                      <a:pPr>
+                        <a:defRPr sz="1400" b="1">
+                          <a:latin typeface="Calibri"/>
+                        </a:defRPr>
+                      </a:pPr>
+                      <a:r>
+                        <a:t>Sí</a:t>
+                      </a:r>
+                    </a:p>
+                  </a:txBody>
+                  <a:tcPr/>
+                </a:tc>
+                <a:tc>
+                  <a:txBody>
+                    <a:bodyPr/>
+                    <a:lstStyle/>
+                    <a:p>
+                      <a:pPr>
+                        <a:defRPr sz="1400" b="1">
+                          <a:latin typeface="Calibri"/>
+                        </a:defRPr>
+                      </a:pPr>
+                      <a:r>
+                        <a:t>Qué cambió</a:t>
+                      </a:r>
+                    </a:p>
+                  </a:txBody>
+                  <a:tcPr/>
+                </a:tc>
+              </a:tr>
+              <a:tr h="457200">
+                <a:tc>
+                  <a:txBody>
+                    <a:bodyPr/>
+                    <a:lstStyle/>
+                    <a:p>
+                      <a:pPr>
+                        <a:defRPr sz="1400">
+                          <a:latin typeface="Calibri"/>
+                        </a:defRPr>
+                      </a:pPr>
+                      <a:r>
+                        <a:t>T0</a:t>
+                      </a:r>
+                    </a:p>
+                  </a:txBody>
+                  <a:tcPr/>
+                </a:tc>
+                <a:tc>
+                  <a:txBody>
+                    <a:bodyPr/>
+                    <a:lstStyle/>
+                    <a:p>
+                      <a:pPr>
+                        <a:defRPr sz="1400">
+                          <a:latin typeface="Calibri"/>
+                        </a:defRPr>
+                      </a:pPr>
+                      <a:r>
+                        <a:t>45 211</a:t>
+                      </a:r>
+                    </a:p>
+                  </a:txBody>
+                  <a:tcPr/>
+                </a:tc>
+                <a:tc>
+                  <a:txBody>
+                    <a:bodyPr/>
+                    <a:lstStyle/>
+                    <a:p>
+                      <a:pPr>
+                        <a:defRPr sz="1400">
+                          <a:latin typeface="Calibri"/>
+                        </a:defRPr>
+                      </a:pPr>
+                      <a:r>
+                        <a:t>16</a:t>
+                      </a:r>
+                    </a:p>
+                  </a:txBody>
+                  <a:tcPr/>
+                </a:tc>
+                <a:tc>
+                  <a:txBody>
+                    <a:bodyPr/>
+                    <a:lstStyle/>
+                    <a:p>
+                      <a:pPr>
+                        <a:defRPr sz="1400">
+                          <a:latin typeface="Calibri"/>
+                        </a:defRPr>
+                      </a:pPr>
+                      <a:r>
+                        <a:t>39 922</a:t>
+                      </a:r>
+                    </a:p>
+                  </a:txBody>
+                  <a:tcPr/>
+                </a:tc>
+                <a:tc>
+                  <a:txBody>
+                    <a:bodyPr/>
+                    <a:lstStyle/>
+                    <a:p>
+                      <a:pPr>
+                        <a:defRPr sz="1400">
+                          <a:latin typeface="Calibri"/>
+                        </a:defRPr>
+                      </a:pPr>
+                      <a:r>
+                        <a:t>5 289</a:t>
+                      </a:r>
+                    </a:p>
+                  </a:txBody>
+                  <a:tcPr/>
+                </a:tc>
+                <a:tc>
+                  <a:txBody>
+                    <a:bodyPr/>
+                    <a:lstStyle/>
+                    <a:p>
+                      <a:pPr>
+                        <a:defRPr sz="1400">
+                          <a:latin typeface="Calibri"/>
+                        </a:defRPr>
+                      </a:pPr>
+                      <a:r>
+                        <a:t>dato crudo</a:t>
+                      </a:r>
+                    </a:p>
+                  </a:txBody>
+                  <a:tcPr/>
+                </a:tc>
+              </a:tr>
+              <a:tr h="457200">
+                <a:tc>
+                  <a:txBody>
+                    <a:bodyPr/>
+                    <a:lstStyle/>
+                    <a:p>
+                      <a:pPr>
+                        <a:defRPr sz="1400">
+                          <a:latin typeface="Calibri"/>
+                        </a:defRPr>
+                      </a:pPr>
+                      <a:r>
+                        <a:t>T1</a:t>
+                      </a:r>
+                    </a:p>
+                  </a:txBody>
+                  <a:tcPr/>
+                </a:tc>
+                <a:tc>
+                  <a:txBody>
+                    <a:bodyPr/>
+                    <a:lstStyle/>
+                    <a:p>
+                      <a:pPr>
+                        <a:defRPr sz="1400">
+                          <a:latin typeface="Calibri"/>
+                        </a:defRPr>
+                      </a:pPr>
+                      <a:r>
+                        <a:t>44 923</a:t>
+                      </a:r>
+                    </a:p>
+                  </a:txBody>
+                  <a:tcPr/>
+                </a:tc>
+                <a:tc>
+                  <a:txBody>
+                    <a:bodyPr/>
+                    <a:lstStyle/>
+                    <a:p>
+                      <a:pPr>
+                        <a:defRPr sz="1400">
+                          <a:latin typeface="Calibri"/>
+                        </a:defRPr>
+                      </a:pPr>
+                      <a:r>
+                        <a:t>15</a:t>
+                      </a:r>
+                    </a:p>
+                  </a:txBody>
+                  <a:tcPr/>
+                </a:tc>
+                <a:tc>
+                  <a:txBody>
+                    <a:bodyPr/>
+                    <a:lstStyle/>
+                    <a:p>
+                      <a:pPr>
+                        <a:defRPr sz="1400">
+                          <a:latin typeface="Calibri"/>
+                        </a:defRPr>
+                      </a:pPr>
+                      <a:r>
+                        <a:t>39 668</a:t>
+                      </a:r>
+                    </a:p>
+                  </a:txBody>
+                  <a:tcPr/>
+                </a:tc>
+                <a:tc>
+                  <a:txBody>
+                    <a:bodyPr/>
+                    <a:lstStyle/>
+                    <a:p>
+                      <a:pPr>
+                        <a:defRPr sz="1400">
+                          <a:latin typeface="Calibri"/>
+                        </a:defRPr>
+                      </a:pPr>
+                      <a:r>
+                        <a:t>5 255</a:t>
+                      </a:r>
+                    </a:p>
+                  </a:txBody>
+                  <a:tcPr/>
+                </a:tc>
+                <a:tc>
+                  <a:txBody>
+                    <a:bodyPr/>
+                    <a:lstStyle/>
+                    <a:p>
+                      <a:pPr>
+                        <a:defRPr sz="1400">
+                          <a:latin typeface="Calibri"/>
+                        </a:defRPr>
+                      </a:pPr>
+                      <a:r>
+                        <a:t>sin duration, dia_anio, education ordinal, pdays con umbral, atípicos recortados</a:t>
+                      </a:r>
+                    </a:p>
+                  </a:txBody>
+                  <a:tcPr/>
+                </a:tc>
+              </a:tr>
+              <a:tr h="457200">
+                <a:tc>
+                  <a:txBody>
+                    <a:bodyPr/>
+                    <a:lstStyle/>
+                    <a:p>
+                      <a:pPr>
+                        <a:defRPr sz="1400">
+                          <a:latin typeface="Calibri"/>
+                        </a:defRPr>
+                      </a:pPr>
+                      <a:r>
+                        <a:t>T2z y T2n</a:t>
+                      </a:r>
+                    </a:p>
+                  </a:txBody>
+                  <a:tcPr/>
+                </a:tc>
+                <a:tc>
+                  <a:txBody>
+                    <a:bodyPr/>
+                    <a:lstStyle/>
+                    <a:p>
+                      <a:pPr>
+                        <a:defRPr sz="1400">
+                          <a:latin typeface="Calibri"/>
+                        </a:defRPr>
+                      </a:pPr>
+                      <a:r>
+                        <a:t>44 923</a:t>
+                      </a:r>
+                    </a:p>
+                  </a:txBody>
+                  <a:tcPr/>
+                </a:tc>
+                <a:tc>
+                  <a:txBody>
+                    <a:bodyPr/>
+                    <a:lstStyle/>
+                    <a:p>
+                      <a:pPr>
+                        <a:defRPr sz="1400">
+                          <a:latin typeface="Calibri"/>
+                        </a:defRPr>
+                      </a:pPr>
+                      <a:r>
+                        <a:t>31</a:t>
+                      </a:r>
+                    </a:p>
+                  </a:txBody>
+                  <a:tcPr/>
+                </a:tc>
+                <a:tc>
+                  <a:txBody>
+                    <a:bodyPr/>
+                    <a:lstStyle/>
+                    <a:p>
+                      <a:pPr>
+                        <a:defRPr sz="1400">
+                          <a:latin typeface="Calibri"/>
+                        </a:defRPr>
+                      </a:pPr>
+                      <a:r>
+                        <a:t>39 668</a:t>
+                      </a:r>
+                    </a:p>
+                  </a:txBody>
+                  <a:tcPr/>
+                </a:tc>
+                <a:tc>
+                  <a:txBody>
+                    <a:bodyPr/>
+                    <a:lstStyle/>
+                    <a:p>
+                      <a:pPr>
+                        <a:defRPr sz="1400">
+                          <a:latin typeface="Calibri"/>
+                        </a:defRPr>
+                      </a:pPr>
+                      <a:r>
+                        <a:t>5 255</a:t>
+                      </a:r>
+                    </a:p>
+                  </a:txBody>
+                  <a:tcPr/>
+                </a:tc>
+                <a:tc>
+                  <a:txBody>
+                    <a:bodyPr/>
+                    <a:lstStyle/>
+                    <a:p>
+                      <a:pPr>
+                        <a:defRPr sz="1400">
+                          <a:latin typeface="Calibri"/>
+                        </a:defRPr>
+                      </a:pPr>
+                      <a:r>
+                        <a:t>one hot, binarias en 0 y 1, z score o rango 0 a 1</a:t>
+                      </a:r>
+                    </a:p>
+                  </a:txBody>
+                  <a:tcPr/>
+                </a:tc>
+              </a:tr>
+              <a:tr h="457200">
+                <a:tc>
+                  <a:txBody>
+                    <a:bodyPr/>
+                    <a:lstStyle/>
+                    <a:p>
+                      <a:pPr>
+                        <a:defRPr sz="1400">
+                          <a:latin typeface="Calibri"/>
+                        </a:defRPr>
+                      </a:pPr>
+                      <a:r>
+                        <a:t>T3_1z y T3_1n</a:t>
+                      </a:r>
+                    </a:p>
+                  </a:txBody>
+                  <a:tcPr/>
+                </a:tc>
+                <a:tc>
+                  <a:txBody>
+                    <a:bodyPr/>
+                    <a:lstStyle/>
+                    <a:p>
+                      <a:pPr>
+                        <a:defRPr sz="1400">
+                          <a:latin typeface="Calibri"/>
+                        </a:defRPr>
+                      </a:pPr>
+                      <a:r>
+                        <a:t>10 510</a:t>
+                      </a:r>
+                    </a:p>
+                  </a:txBody>
+                  <a:tcPr/>
+                </a:tc>
+                <a:tc>
+                  <a:txBody>
+                    <a:bodyPr/>
+                    <a:lstStyle/>
+                    <a:p>
+                      <a:pPr>
+                        <a:defRPr sz="1400">
+                          <a:latin typeface="Calibri"/>
+                        </a:defRPr>
+                      </a:pPr>
+                      <a:r>
+                        <a:t>31</a:t>
+                      </a:r>
+                    </a:p>
+                  </a:txBody>
+                  <a:tcPr/>
+                </a:tc>
+                <a:tc>
+                  <a:txBody>
+                    <a:bodyPr/>
+                    <a:lstStyle/>
+                    <a:p>
+                      <a:pPr>
+                        <a:defRPr sz="1400">
+                          <a:latin typeface="Calibri"/>
+                        </a:defRPr>
+                      </a:pPr>
+                      <a:r>
+                        <a:t>5 255</a:t>
+                      </a:r>
+                    </a:p>
+                  </a:txBody>
+                  <a:tcPr/>
+                </a:tc>
+                <a:tc>
+                  <a:txBody>
+                    <a:bodyPr/>
+                    <a:lstStyle/>
+                    <a:p>
+                      <a:pPr>
+                        <a:defRPr sz="1400">
+                          <a:latin typeface="Calibri"/>
+                        </a:defRPr>
+                      </a:pPr>
+                      <a:r>
+                        <a:t>5 255</a:t>
+                      </a:r>
+                    </a:p>
+                  </a:txBody>
+                  <a:tcPr/>
+                </a:tc>
+                <a:tc>
+                  <a:txBody>
+                    <a:bodyPr/>
+                    <a:lstStyle/>
+                    <a:p>
+                      <a:pPr>
+                        <a:defRPr sz="1400">
+                          <a:latin typeface="Calibri"/>
+                        </a:defRPr>
+                      </a:pPr>
+                      <a:r>
+                        <a:t>submuestreo de la clase no</a:t>
+                      </a:r>
+                    </a:p>
+                  </a:txBody>
+                  <a:tcPr/>
+                </a:tc>
+              </a:tr>
+              <a:tr h="457200">
+                <a:tc>
+                  <a:txBody>
+                    <a:bodyPr/>
+                    <a:lstStyle/>
+                    <a:p>
+                      <a:pPr>
+                        <a:defRPr sz="1400">
+                          <a:latin typeface="Calibri"/>
+                        </a:defRPr>
+                      </a:pPr>
+                      <a:r>
+                        <a:t>T3_2z y T3_2n</a:t>
+                      </a:r>
+                    </a:p>
+                  </a:txBody>
+                  <a:tcPr/>
+                </a:tc>
+                <a:tc>
+                  <a:txBody>
+                    <a:bodyPr/>
+                    <a:lstStyle/>
+                    <a:p>
+                      <a:pPr>
+                        <a:defRPr sz="1400">
+                          <a:latin typeface="Calibri"/>
+                        </a:defRPr>
+                      </a:pPr>
+                      <a:r>
+                        <a:t>79 336</a:t>
+                      </a:r>
+                    </a:p>
+                  </a:txBody>
+                  <a:tcPr/>
+                </a:tc>
+                <a:tc>
+                  <a:txBody>
+                    <a:bodyPr/>
+                    <a:lstStyle/>
+                    <a:p>
+                      <a:pPr>
+                        <a:defRPr sz="1400">
+                          <a:latin typeface="Calibri"/>
+                        </a:defRPr>
+                      </a:pPr>
+                      <a:r>
+                        <a:t>31</a:t>
+                      </a:r>
+                    </a:p>
+                  </a:txBody>
+                  <a:tcPr/>
+                </a:tc>
+                <a:tc>
+                  <a:txBody>
+                    <a:bodyPr/>
+                    <a:lstStyle/>
+                    <a:p>
+                      <a:pPr>
+                        <a:defRPr sz="1400">
+                          <a:latin typeface="Calibri"/>
+                        </a:defRPr>
+                      </a:pPr>
+                      <a:r>
+                        <a:t>39 668</a:t>
+                      </a:r>
+                    </a:p>
+                  </a:txBody>
+                  <a:tcPr/>
+                </a:tc>
+                <a:tc>
+                  <a:txBody>
+                    <a:bodyPr/>
+                    <a:lstStyle/>
+                    <a:p>
+                      <a:pPr>
+                        <a:defRPr sz="1400">
+                          <a:latin typeface="Calibri"/>
+                        </a:defRPr>
+                      </a:pPr>
+                      <a:r>
+                        <a:t>39 668</a:t>
+                      </a:r>
+                    </a:p>
+                  </a:txBody>
+                  <a:tcPr/>
+                </a:tc>
+                <a:tc>
+                  <a:txBody>
+                    <a:bodyPr/>
+                    <a:lstStyle/>
+                    <a:p>
+                      <a:pPr>
+                        <a:defRPr sz="1400">
+                          <a:latin typeface="Calibri"/>
+                        </a:defRPr>
+                      </a:pPr>
+                      <a:r>
+                        <a:t>sobremuestreo sintético de la clase sí</a:t>
+                      </a:r>
+                    </a:p>
+                  </a:txBody>
+                  <a:tcPr/>
+                </a:tc>
+              </a:tr>
+            </a:tbl>
+          </a:graphicData>
+        </a:graphic>
+      </p:graphicFrame>
+      <p:sp>
+        <p:nvSpPr>
+          <p:cNvPr id="5" name="TextBox 4"/>
           <p:cNvSpPr txBox="1"/>
           <p:nvPr/>
         </p:nvSpPr>
         <p:spPr>
           <a:xfrm>
-            <a:off x="640080" y="1463040"/>
-            <a:ext cx="10972800" cy="5029200"/>
+            <a:off x="640080" y="4389120"/>
+            <a:ext cx="10972800" cy="1828800"/>
           </a:xfrm>
           <a:prstGeom prst="rect">
             <a:avLst/>
@@ -5245,12 +5402,12 @@
               <a:spcAft>
                 <a:spcPts val="600"/>
               </a:spcAft>
-              <a:defRPr sz="1700">
-                <a:latin typeface="Calibri"/>
-              </a:defRPr>
-            </a:pPr>
-            <a:r>
-              <a:t>• Importar cada tabla desde el workspace con y como respuesta</a:t>
+              <a:defRPr sz="1600">
+                <a:latin typeface="Calibri"/>
+              </a:defRPr>
+            </a:pPr>
+            <a:r>
+              <a:t>• Un solo live script, procesar_bank.mlx, genera las cinco versiones y las figuras</a:t>
             </a:r>
           </a:p>
           <a:p>
@@ -5258,12 +5415,12 @@
               <a:spcAft>
                 <a:spcPts val="600"/>
               </a:spcAft>
-              <a:defRPr sz="1700">
-                <a:latin typeface="Calibri"/>
-              </a:defRPr>
-            </a:pPr>
-            <a:r>
-              <a:t>• Validación cruzada de 5 particiones en todas las pruebas</a:t>
+              <a:defRPr sz="1600">
+                <a:latin typeface="Calibri"/>
+              </a:defRPr>
+            </a:pPr>
+            <a:r>
+              <a:t>• Cada tabla lleva la clase y como última columna</a:t>
             </a:r>
           </a:p>
           <a:p>
@@ -5271,77 +5428,12 @@
               <a:spcAft>
                 <a:spcPts val="600"/>
               </a:spcAft>
-              <a:defRPr sz="1700">
-                <a:latin typeface="Calibri"/>
-              </a:defRPr>
-            </a:pPr>
-            <a:r>
-              <a:t>• Comparar T2z frente a T3z para ver el efecto del balanceo sobre la sensibilidad de la clase sí</a:t>
-            </a:r>
-          </a:p>
-          <a:p>
-            <a:pPr>
-              <a:spcAft>
-                <a:spcPts val="600"/>
-              </a:spcAft>
-              <a:defRPr sz="1700">
-                <a:latin typeface="Calibri"/>
-              </a:defRPr>
-            </a:pPr>
-            <a:r>
-              <a:t>• Comparar T2z frente a T2n para ver si el escalado cambia algo según el modelo</a:t>
-            </a:r>
-          </a:p>
-          <a:p>
-            <a:pPr>
-              <a:spcAft>
-                <a:spcPts val="600"/>
-              </a:spcAft>
-              <a:defRPr sz="1700">
-                <a:latin typeface="Calibri"/>
-              </a:defRPr>
-            </a:pPr>
-            <a:r>
-              <a:t>• Mirar la exactitud, pero sobre todo la matriz de confusión, porque con 88 % de no la exactitud engaña</a:t>
-            </a:r>
-          </a:p>
-          <a:p>
-            <a:pPr>
-              <a:spcAft>
-                <a:spcPts val="600"/>
-              </a:spcAft>
-              <a:defRPr sz="1700">
-                <a:latin typeface="Calibri"/>
-              </a:defRPr>
-            </a:pPr>
-            <a:r>
-              <a:t>• Referencias</a:t>
-            </a:r>
-          </a:p>
-          <a:p>
-            <a:pPr lvl="1">
-              <a:spcAft>
-                <a:spcPts val="600"/>
-              </a:spcAft>
-              <a:defRPr sz="1500">
-                <a:latin typeface="Calibri"/>
-              </a:defRPr>
-            </a:pPr>
-            <a:r>
-              <a:t>– Moro, S., Cortez, P. y Rita, P. (2014). A data driven approach to predict the success of bank telemarketing. Decision Support Systems, 62, 22 a 31</a:t>
-            </a:r>
-          </a:p>
-          <a:p>
-            <a:pPr lvl="1">
-              <a:spcAft>
-                <a:spcPts val="600"/>
-              </a:spcAft>
-              <a:defRPr sz="1500">
-                <a:latin typeface="Calibri"/>
-              </a:defRPr>
-            </a:pPr>
-            <a:r>
-              <a:t>– Tukey, J. W. (1977). Exploratory Data Analysis. Addison Wesley</a:t>
+              <a:defRPr sz="1600">
+                <a:latin typeface="Calibri"/>
+              </a:defRPr>
+            </a:pPr>
+            <a:r>
+              <a:t>• Ninguna versión modifica la clase ni elimina positivos reales, salvo las 34 filas con job unknown</a:t>
             </a:r>
           </a:p>
         </p:txBody>
@@ -5354,7 +5446,7 @@
 </p:sld>
 </file>
 
-<file path=ppt/slides/slide2.xml><?xml version="1.0" encoding="utf-8"?>
+<file path=ppt/slides/slide15.xml><?xml version="1.0" encoding="utf-8"?>
 <p:sld xmlns:a="http://schemas.openxmlformats.org/drawingml/2006/main" xmlns:p="http://schemas.openxmlformats.org/presentationml/2006/main" xmlns:r="http://schemas.openxmlformats.org/officeDocument/2006/relationships">
   <p:cSld>
     <p:spTree>
@@ -5395,7 +5487,7 @@
               </a:defRPr>
             </a:pPr>
             <a:r>
-              <a:t>El dataset</a:t>
+              <a:t>Siguiente paso. Herramienta de clasificación</a:t>
             </a:r>
           </a:p>
           <a:p>
@@ -5408,7 +5500,7 @@
               </a:defRPr>
             </a:pPr>
             <a:r>
-              <a:t>UCI Machine Learning Repository, Bank Marketing (Moro, Cortez y Rita, 2014)</a:t>
+              <a:t>Qué se va a comparar en Classification Learner</a:t>
             </a:r>
           </a:p>
         </p:txBody>
@@ -5465,7 +5557,7 @@
         <p:spPr>
           <a:xfrm>
             <a:off x="640080" y="1463040"/>
-            <a:ext cx="10972800" cy="4846320"/>
+            <a:ext cx="10972800" cy="5029200"/>
           </a:xfrm>
           <a:prstGeom prst="rect">
             <a:avLst/>
@@ -5482,12 +5574,12 @@
               <a:spcAft>
                 <a:spcPts val="600"/>
               </a:spcAft>
-              <a:defRPr sz="1800">
-                <a:latin typeface="Calibri"/>
-              </a:defRPr>
-            </a:pPr>
-            <a:r>
-              <a:t>• Campañas telefónicas de un banco portugués entre mayo de 2008 y noviembre de 2010</a:t>
+              <a:defRPr sz="1700">
+                <a:latin typeface="Calibri"/>
+              </a:defRPr>
+            </a:pPr>
+            <a:r>
+              <a:t>• Importar cada tabla desde el workspace con y como respuesta</a:t>
             </a:r>
           </a:p>
           <a:p>
@@ -5495,12 +5587,12 @@
               <a:spcAft>
                 <a:spcPts val="600"/>
               </a:spcAft>
-              <a:defRPr sz="1800">
-                <a:latin typeface="Calibri"/>
-              </a:defRPr>
-            </a:pPr>
-            <a:r>
-              <a:t>• Objetivo. Predecir si el cliente suscribe un depósito a plazo (variable y)</a:t>
+              <a:defRPr sz="1700">
+                <a:latin typeface="Calibri"/>
+              </a:defRPr>
+            </a:pPr>
+            <a:r>
+              <a:t>• Validación cruzada de 5 particiones en todas las pruebas</a:t>
             </a:r>
           </a:p>
           <a:p>
@@ -5508,12 +5600,12 @@
               <a:spcAft>
                 <a:spcPts val="600"/>
               </a:spcAft>
-              <a:defRPr sz="1800">
-                <a:latin typeface="Calibri"/>
-              </a:defRPr>
-            </a:pPr>
-            <a:r>
-              <a:t>• 45 211 registros, 16 atributos de entrada y la clase</a:t>
+              <a:defRPr sz="1700">
+                <a:latin typeface="Calibri"/>
+              </a:defRPr>
+            </a:pPr>
+            <a:r>
+              <a:t>• El escalado y el sobremuestreo se hicieron sobre todo el conjunto porque la partición se delega a la herramienta, así que las cifras de T3_2 salen algo optimistas</a:t>
             </a:r>
           </a:p>
           <a:p>
@@ -5521,12 +5613,12 @@
               <a:spcAft>
                 <a:spcPts val="600"/>
               </a:spcAft>
-              <a:defRPr sz="1800">
-                <a:latin typeface="Calibri"/>
-              </a:defRPr>
-            </a:pPr>
-            <a:r>
-              <a:t>• Sin valores faltantes explícitos, pero varias categóricas usan la etiqueta unknown</a:t>
+              <a:defRPr sz="1700">
+                <a:latin typeface="Calibri"/>
+              </a:defRPr>
+            </a:pPr>
+            <a:r>
+              <a:t>• Comparar T2z, T3_1z y T3_2z para ver el efecto de cada balanceo sobre la sensibilidad de la clase sí</a:t>
             </a:r>
           </a:p>
           <a:p>
@@ -5534,12 +5626,12 @@
               <a:spcAft>
                 <a:spcPts val="600"/>
               </a:spcAft>
-              <a:defRPr sz="1800">
-                <a:latin typeface="Calibri"/>
-              </a:defRPr>
-            </a:pPr>
-            <a:r>
-              <a:t>• Clase muy desbalanceada, 39 922 no frente a 5 289 sí (11.7 % de positivos)</a:t>
+              <a:defRPr sz="1700">
+                <a:latin typeface="Calibri"/>
+              </a:defRPr>
+            </a:pPr>
+            <a:r>
+              <a:t>• Comparar T2z frente a T2n para evaluar la sensibilidad de cada modelo al escalado</a:t>
             </a:r>
           </a:p>
           <a:p>
@@ -5547,12 +5639,12 @@
               <a:spcAft>
                 <a:spcPts val="600"/>
               </a:spcAft>
-              <a:defRPr sz="1800">
-                <a:latin typeface="Calibri"/>
-              </a:defRPr>
-            </a:pPr>
-            <a:r>
-              <a:t>• Archivo bank-full.csv, separado por punto y coma</a:t>
+              <a:defRPr sz="1700">
+                <a:latin typeface="Calibri"/>
+              </a:defRPr>
+            </a:pPr>
+            <a:r>
+              <a:t>• Mirar la exactitud, pero sobre todo la matriz de confusión, porque con 88 % de la clase no la exactitud resulta poco informativa</a:t>
             </a:r>
           </a:p>
           <a:p>
@@ -5560,12 +5652,12 @@
               <a:spcAft>
                 <a:spcPts val="600"/>
               </a:spcAft>
-              <a:defRPr sz="1800">
-                <a:latin typeface="Calibri"/>
-              </a:defRPr>
-            </a:pPr>
-            <a:r>
-              <a:t>• Plan de trabajo en cuatro versiones del dato</a:t>
+              <a:defRPr sz="1700">
+                <a:latin typeface="Calibri"/>
+              </a:defRPr>
+            </a:pPr>
+            <a:r>
+              <a:t>• Referencias</a:t>
             </a:r>
           </a:p>
           <a:p>
@@ -5573,12 +5665,12 @@
               <a:spcAft>
                 <a:spcPts val="600"/>
               </a:spcAft>
-              <a:defRPr sz="1600">
-                <a:latin typeface="Calibri"/>
-              </a:defRPr>
-            </a:pPr>
-            <a:r>
-              <a:t>– T0 crudo, tal como viene</a:t>
+              <a:defRPr sz="1500">
+                <a:latin typeface="Calibri"/>
+              </a:defRPr>
+            </a:pPr>
+            <a:r>
+              <a:t>– Moro, S., Cortez, P. y Rita, P. (2014). A data driven approach to predict the success of bank telemarketing. Decision Support Systems, 62, 22 a 31</a:t>
             </a:r>
           </a:p>
           <a:p>
@@ -5586,38 +5678,12 @@
               <a:spcAft>
                 <a:spcPts val="600"/>
               </a:spcAft>
-              <a:defRPr sz="1600">
-                <a:latin typeface="Calibri"/>
-              </a:defRPr>
-            </a:pPr>
-            <a:r>
-              <a:t>– T1 arreglo de columnas, filas, faltantes y atípicos</a:t>
-            </a:r>
-          </a:p>
-          <a:p>
-            <a:pPr lvl="1">
-              <a:spcAft>
-                <a:spcPts val="600"/>
-              </a:spcAft>
-              <a:defRPr sz="1600">
-                <a:latin typeface="Calibri"/>
-              </a:defRPr>
-            </a:pPr>
-            <a:r>
-              <a:t>– T2 codificación, estandarización y normalización</a:t>
-            </a:r>
-          </a:p>
-          <a:p>
-            <a:pPr lvl="1">
-              <a:spcAft>
-                <a:spcPts val="600"/>
-              </a:spcAft>
-              <a:defRPr sz="1600">
-                <a:latin typeface="Calibri"/>
-              </a:defRPr>
-            </a:pPr>
-            <a:r>
-              <a:t>– T3 balanceo de clases</a:t>
+              <a:defRPr sz="1500">
+                <a:latin typeface="Calibri"/>
+              </a:defRPr>
+            </a:pPr>
+            <a:r>
+              <a:t>– Tukey, J. W. (1977). Exploratory Data Analysis. Addison Wesley</a:t>
             </a:r>
           </a:p>
         </p:txBody>
@@ -5630,7 +5696,7 @@
 </p:sld>
 </file>
 
-<file path=ppt/slides/slide3.xml><?xml version="1.0" encoding="utf-8"?>
+<file path=ppt/slides/slide2.xml><?xml version="1.0" encoding="utf-8"?>
 <p:sld xmlns:a="http://schemas.openxmlformats.org/drawingml/2006/main" xmlns:p="http://schemas.openxmlformats.org/presentationml/2006/main" xmlns:r="http://schemas.openxmlformats.org/officeDocument/2006/relationships">
   <p:cSld>
     <p:spTree>
@@ -5671,7 +5737,7 @@
               </a:defRPr>
             </a:pPr>
             <a:r>
-              <a:t>Variables</a:t>
+              <a:t>El dataset</a:t>
             </a:r>
           </a:p>
           <a:p>
@@ -5684,7 +5750,7 @@
               </a:defRPr>
             </a:pPr>
             <a:r>
-              <a:t>Tres grupos según la documentación original</a:t>
+              <a:t>UCI Machine Learning Repository, Bank Marketing (Moro, Cortez y Rita, 2014)</a:t>
             </a:r>
           </a:p>
         </p:txBody>
@@ -5732,1014 +5798,172 @@
           </a:p>
         </p:txBody>
       </p:sp>
-      <p:graphicFrame>
-        <p:nvGraphicFramePr>
-          <p:cNvPr id="4" name="Table 3"/>
-          <p:cNvGraphicFramePr>
-            <a:graphicFrameLocks noGrp="1"/>
-          </p:cNvGraphicFramePr>
+      <p:sp>
+        <p:nvSpPr>
+          <p:cNvPr id="4" name="TextBox 3"/>
+          <p:cNvSpPr txBox="1"/>
           <p:nvPr/>
-        </p:nvGraphicFramePr>
-        <p:xfrm>
-          <a:off x="457200" y="1371600"/>
-          <a:ext cx="11247120" cy="4846320"/>
-        </p:xfrm>
-        <a:graphic>
-          <a:graphicData uri="http://schemas.openxmlformats.org/drawingml/2006/table">
-            <a:tbl>
-              <a:tblPr firstRow="1" bandRow="1">
-                <a:tableStyleId>{5C22544A-7EE6-4342-B048-85BDC9FD1C3A}</a:tableStyleId>
-              </a:tblPr>
-              <a:tblGrid>
-                <a:gridCol w="2811780"/>
-                <a:gridCol w="2811780"/>
-                <a:gridCol w="2811780"/>
-                <a:gridCol w="2811780"/>
-              </a:tblGrid>
-              <a:tr h="346165">
-                <a:tc>
-                  <a:txBody>
-                    <a:bodyPr/>
-                    <a:lstStyle/>
-                    <a:p>
-                      <a:pPr>
-                        <a:defRPr sz="1200" b="1">
-                          <a:latin typeface="Calibri"/>
-                        </a:defRPr>
-                      </a:pPr>
-                      <a:r>
-                        <a:t>Grupo</a:t>
-                      </a:r>
-                    </a:p>
-                  </a:txBody>
-                  <a:tcPr/>
-                </a:tc>
-                <a:tc>
-                  <a:txBody>
-                    <a:bodyPr/>
-                    <a:lstStyle/>
-                    <a:p>
-                      <a:pPr>
-                        <a:defRPr sz="1200" b="1">
-                          <a:latin typeface="Calibri"/>
-                        </a:defRPr>
-                      </a:pPr>
-                      <a:r>
-                        <a:t>Variable</a:t>
-                      </a:r>
-                    </a:p>
-                  </a:txBody>
-                  <a:tcPr/>
-                </a:tc>
-                <a:tc>
-                  <a:txBody>
-                    <a:bodyPr/>
-                    <a:lstStyle/>
-                    <a:p>
-                      <a:pPr>
-                        <a:defRPr sz="1200" b="1">
-                          <a:latin typeface="Calibri"/>
-                        </a:defRPr>
-                      </a:pPr>
-                      <a:r>
-                        <a:t>Tipo</a:t>
-                      </a:r>
-                    </a:p>
-                  </a:txBody>
-                  <a:tcPr/>
-                </a:tc>
-                <a:tc>
-                  <a:txBody>
-                    <a:bodyPr/>
-                    <a:lstStyle/>
-                    <a:p>
-                      <a:pPr>
-                        <a:defRPr sz="1200" b="1">
-                          <a:latin typeface="Calibri"/>
-                        </a:defRPr>
-                      </a:pPr>
-                      <a:r>
-                        <a:t>Observación</a:t>
-                      </a:r>
-                    </a:p>
-                  </a:txBody>
-                  <a:tcPr/>
-                </a:tc>
-              </a:tr>
-              <a:tr h="346165">
-                <a:tc>
-                  <a:txBody>
-                    <a:bodyPr/>
-                    <a:lstStyle/>
-                    <a:p>
-                      <a:pPr>
-                        <a:defRPr sz="1200">
-                          <a:latin typeface="Calibri"/>
-                        </a:defRPr>
-                      </a:pPr>
-                      <a:r>
-                        <a:t>Cliente</a:t>
-                      </a:r>
-                    </a:p>
-                  </a:txBody>
-                  <a:tcPr/>
-                </a:tc>
-                <a:tc>
-                  <a:txBody>
-                    <a:bodyPr/>
-                    <a:lstStyle/>
-                    <a:p>
-                      <a:pPr>
-                        <a:defRPr sz="1200">
-                          <a:latin typeface="Calibri"/>
-                        </a:defRPr>
-                      </a:pPr>
-                      <a:r>
-                        <a:t>age</a:t>
-                      </a:r>
-                    </a:p>
-                  </a:txBody>
-                  <a:tcPr/>
-                </a:tc>
-                <a:tc>
-                  <a:txBody>
-                    <a:bodyPr/>
-                    <a:lstStyle/>
-                    <a:p>
-                      <a:pPr>
-                        <a:defRPr sz="1200">
-                          <a:latin typeface="Calibri"/>
-                        </a:defRPr>
-                      </a:pPr>
-                      <a:r>
-                        <a:t>numérica</a:t>
-                      </a:r>
-                    </a:p>
-                  </a:txBody>
-                  <a:tcPr/>
-                </a:tc>
-                <a:tc>
-                  <a:txBody>
-                    <a:bodyPr/>
-                    <a:lstStyle/>
-                    <a:p>
-                      <a:pPr>
-                        <a:defRPr sz="1200">
-                          <a:latin typeface="Calibri"/>
-                        </a:defRPr>
-                      </a:pPr>
-                      <a:r>
-                        <a:t>18 a 95 años</a:t>
-                      </a:r>
-                    </a:p>
-                  </a:txBody>
-                  <a:tcPr/>
-                </a:tc>
-              </a:tr>
-              <a:tr h="346165">
-                <a:tc>
-                  <a:txBody>
-                    <a:bodyPr/>
-                    <a:lstStyle/>
-                    <a:p>
-                      <a:pPr>
-                        <a:defRPr sz="1200">
-                          <a:latin typeface="Calibri"/>
-                        </a:defRPr>
-                      </a:pPr>
-                      <a:r>
-                        <a:t>Cliente</a:t>
-                      </a:r>
-                    </a:p>
-                  </a:txBody>
-                  <a:tcPr/>
-                </a:tc>
-                <a:tc>
-                  <a:txBody>
-                    <a:bodyPr/>
-                    <a:lstStyle/>
-                    <a:p>
-                      <a:pPr>
-                        <a:defRPr sz="1200">
-                          <a:latin typeface="Calibri"/>
-                        </a:defRPr>
-                      </a:pPr>
-                      <a:r>
-                        <a:t>job</a:t>
-                      </a:r>
-                    </a:p>
-                  </a:txBody>
-                  <a:tcPr/>
-                </a:tc>
-                <a:tc>
-                  <a:txBody>
-                    <a:bodyPr/>
-                    <a:lstStyle/>
-                    <a:p>
-                      <a:pPr>
-                        <a:defRPr sz="1200">
-                          <a:latin typeface="Calibri"/>
-                        </a:defRPr>
-                      </a:pPr>
-                      <a:r>
-                        <a:t>categórica 12 niveles</a:t>
-                      </a:r>
-                    </a:p>
-                  </a:txBody>
-                  <a:tcPr/>
-                </a:tc>
-                <a:tc>
-                  <a:txBody>
-                    <a:bodyPr/>
-                    <a:lstStyle/>
-                    <a:p>
-                      <a:pPr>
-                        <a:defRPr sz="1200">
-                          <a:latin typeface="Calibri"/>
-                        </a:defRPr>
-                      </a:pPr>
-                      <a:r>
-                        <a:t>incluye unknown (288)</a:t>
-                      </a:r>
-                    </a:p>
-                  </a:txBody>
-                  <a:tcPr/>
-                </a:tc>
-              </a:tr>
-              <a:tr h="346165">
-                <a:tc>
-                  <a:txBody>
-                    <a:bodyPr/>
-                    <a:lstStyle/>
-                    <a:p>
-                      <a:pPr>
-                        <a:defRPr sz="1200">
-                          <a:latin typeface="Calibri"/>
-                        </a:defRPr>
-                      </a:pPr>
-                      <a:r>
-                        <a:t>Cliente</a:t>
-                      </a:r>
-                    </a:p>
-                  </a:txBody>
-                  <a:tcPr/>
-                </a:tc>
-                <a:tc>
-                  <a:txBody>
-                    <a:bodyPr/>
-                    <a:lstStyle/>
-                    <a:p>
-                      <a:pPr>
-                        <a:defRPr sz="1200">
-                          <a:latin typeface="Calibri"/>
-                        </a:defRPr>
-                      </a:pPr>
-                      <a:r>
-                        <a:t>marital</a:t>
-                      </a:r>
-                    </a:p>
-                  </a:txBody>
-                  <a:tcPr/>
-                </a:tc>
-                <a:tc>
-                  <a:txBody>
-                    <a:bodyPr/>
-                    <a:lstStyle/>
-                    <a:p>
-                      <a:pPr>
-                        <a:defRPr sz="1200">
-                          <a:latin typeface="Calibri"/>
-                        </a:defRPr>
-                      </a:pPr>
-                      <a:r>
-                        <a:t>categórica 3 niveles</a:t>
-                      </a:r>
-                    </a:p>
-                  </a:txBody>
-                  <a:tcPr/>
-                </a:tc>
-                <a:tc>
-                  <a:txBody>
-                    <a:bodyPr/>
-                    <a:lstStyle/>
-                    <a:p>
-                      <a:pPr>
-                        <a:defRPr sz="1200">
-                          <a:latin typeface="Calibri"/>
-                        </a:defRPr>
-                      </a:pPr>
-                      <a:r>
-                        <a:t>divorced agrupa divorciados y viudos</a:t>
-                      </a:r>
-                    </a:p>
-                  </a:txBody>
-                  <a:tcPr/>
-                </a:tc>
-              </a:tr>
-              <a:tr h="346165">
-                <a:tc>
-                  <a:txBody>
-                    <a:bodyPr/>
-                    <a:lstStyle/>
-                    <a:p>
-                      <a:pPr>
-                        <a:defRPr sz="1200">
-                          <a:latin typeface="Calibri"/>
-                        </a:defRPr>
-                      </a:pPr>
-                      <a:r>
-                        <a:t>Cliente</a:t>
-                      </a:r>
-                    </a:p>
-                  </a:txBody>
-                  <a:tcPr/>
-                </a:tc>
-                <a:tc>
-                  <a:txBody>
-                    <a:bodyPr/>
-                    <a:lstStyle/>
-                    <a:p>
-                      <a:pPr>
-                        <a:defRPr sz="1200">
-                          <a:latin typeface="Calibri"/>
-                        </a:defRPr>
-                      </a:pPr>
-                      <a:r>
-                        <a:t>education</a:t>
-                      </a:r>
-                    </a:p>
-                  </a:txBody>
-                  <a:tcPr/>
-                </a:tc>
-                <a:tc>
-                  <a:txBody>
-                    <a:bodyPr/>
-                    <a:lstStyle/>
-                    <a:p>
-                      <a:pPr>
-                        <a:defRPr sz="1200">
-                          <a:latin typeface="Calibri"/>
-                        </a:defRPr>
-                      </a:pPr>
-                      <a:r>
-                        <a:t>categórica ordenable</a:t>
-                      </a:r>
-                    </a:p>
-                  </a:txBody>
-                  <a:tcPr/>
-                </a:tc>
-                <a:tc>
-                  <a:txBody>
-                    <a:bodyPr/>
-                    <a:lstStyle/>
-                    <a:p>
-                      <a:pPr>
-                        <a:defRPr sz="1200">
-                          <a:latin typeface="Calibri"/>
-                        </a:defRPr>
-                      </a:pPr>
-                      <a:r>
-                        <a:t>primary, secondary, tertiary, unknown (1 857)</a:t>
-                      </a:r>
-                    </a:p>
-                  </a:txBody>
-                  <a:tcPr/>
-                </a:tc>
-              </a:tr>
-              <a:tr h="346165">
-                <a:tc>
-                  <a:txBody>
-                    <a:bodyPr/>
-                    <a:lstStyle/>
-                    <a:p>
-                      <a:pPr>
-                        <a:defRPr sz="1200">
-                          <a:latin typeface="Calibri"/>
-                        </a:defRPr>
-                      </a:pPr>
-                      <a:r>
-                        <a:t>Cliente</a:t>
-                      </a:r>
-                    </a:p>
-                  </a:txBody>
-                  <a:tcPr/>
-                </a:tc>
-                <a:tc>
-                  <a:txBody>
-                    <a:bodyPr/>
-                    <a:lstStyle/>
-                    <a:p>
-                      <a:pPr>
-                        <a:defRPr sz="1200">
-                          <a:latin typeface="Calibri"/>
-                        </a:defRPr>
-                      </a:pPr>
-                      <a:r>
-                        <a:t>default, housing, loan</a:t>
-                      </a:r>
-                    </a:p>
-                  </a:txBody>
-                  <a:tcPr/>
-                </a:tc>
-                <a:tc>
-                  <a:txBody>
-                    <a:bodyPr/>
-                    <a:lstStyle/>
-                    <a:p>
-                      <a:pPr>
-                        <a:defRPr sz="1200">
-                          <a:latin typeface="Calibri"/>
-                        </a:defRPr>
-                      </a:pPr>
-                      <a:r>
-                        <a:t>binarias yes/no</a:t>
-                      </a:r>
-                    </a:p>
-                  </a:txBody>
-                  <a:tcPr/>
-                </a:tc>
-                <a:tc>
-                  <a:txBody>
-                    <a:bodyPr/>
-                    <a:lstStyle/>
-                    <a:p>
-                      <a:pPr>
-                        <a:defRPr sz="1200">
-                          <a:latin typeface="Calibri"/>
-                        </a:defRPr>
-                      </a:pPr>
-                      <a:r>
-                        <a:t>crédito en mora, hipoteca, préstamo personal</a:t>
-                      </a:r>
-                    </a:p>
-                  </a:txBody>
-                  <a:tcPr/>
-                </a:tc>
-              </a:tr>
-              <a:tr h="346165">
-                <a:tc>
-                  <a:txBody>
-                    <a:bodyPr/>
-                    <a:lstStyle/>
-                    <a:p>
-                      <a:pPr>
-                        <a:defRPr sz="1200">
-                          <a:latin typeface="Calibri"/>
-                        </a:defRPr>
-                      </a:pPr>
-                      <a:r>
-                        <a:t>Cliente</a:t>
-                      </a:r>
-                    </a:p>
-                  </a:txBody>
-                  <a:tcPr/>
-                </a:tc>
-                <a:tc>
-                  <a:txBody>
-                    <a:bodyPr/>
-                    <a:lstStyle/>
-                    <a:p>
-                      <a:pPr>
-                        <a:defRPr sz="1200">
-                          <a:latin typeface="Calibri"/>
-                        </a:defRPr>
-                      </a:pPr>
-                      <a:r>
-                        <a:t>balance</a:t>
-                      </a:r>
-                    </a:p>
-                  </a:txBody>
-                  <a:tcPr/>
-                </a:tc>
-                <a:tc>
-                  <a:txBody>
-                    <a:bodyPr/>
-                    <a:lstStyle/>
-                    <a:p>
-                      <a:pPr>
-                        <a:defRPr sz="1200">
-                          <a:latin typeface="Calibri"/>
-                        </a:defRPr>
-                      </a:pPr>
-                      <a:r>
-                        <a:t>numérica</a:t>
-                      </a:r>
-                    </a:p>
-                  </a:txBody>
-                  <a:tcPr/>
-                </a:tc>
-                <a:tc>
-                  <a:txBody>
-                    <a:bodyPr/>
-                    <a:lstStyle/>
-                    <a:p>
-                      <a:pPr>
-                        <a:defRPr sz="1200">
-                          <a:latin typeface="Calibri"/>
-                        </a:defRPr>
-                      </a:pPr>
-                      <a:r>
-                        <a:t>saldo medio anual en euros, cola muy larga</a:t>
-                      </a:r>
-                    </a:p>
-                  </a:txBody>
-                  <a:tcPr/>
-                </a:tc>
-              </a:tr>
-              <a:tr h="346165">
-                <a:tc>
-                  <a:txBody>
-                    <a:bodyPr/>
-                    <a:lstStyle/>
-                    <a:p>
-                      <a:pPr>
-                        <a:defRPr sz="1200">
-                          <a:latin typeface="Calibri"/>
-                        </a:defRPr>
-                      </a:pPr>
-                      <a:r>
-                        <a:t>Último contacto</a:t>
-                      </a:r>
-                    </a:p>
-                  </a:txBody>
-                  <a:tcPr/>
-                </a:tc>
-                <a:tc>
-                  <a:txBody>
-                    <a:bodyPr/>
-                    <a:lstStyle/>
-                    <a:p>
-                      <a:pPr>
-                        <a:defRPr sz="1200">
-                          <a:latin typeface="Calibri"/>
-                        </a:defRPr>
-                      </a:pPr>
-                      <a:r>
-                        <a:t>contact</a:t>
-                      </a:r>
-                    </a:p>
-                  </a:txBody>
-                  <a:tcPr/>
-                </a:tc>
-                <a:tc>
-                  <a:txBody>
-                    <a:bodyPr/>
-                    <a:lstStyle/>
-                    <a:p>
-                      <a:pPr>
-                        <a:defRPr sz="1200">
-                          <a:latin typeface="Calibri"/>
-                        </a:defRPr>
-                      </a:pPr>
-                      <a:r>
-                        <a:t>categórica 3 niveles</a:t>
-                      </a:r>
-                    </a:p>
-                  </a:txBody>
-                  <a:tcPr/>
-                </a:tc>
-                <a:tc>
-                  <a:txBody>
-                    <a:bodyPr/>
-                    <a:lstStyle/>
-                    <a:p>
-                      <a:pPr>
-                        <a:defRPr sz="1200">
-                          <a:latin typeface="Calibri"/>
-                        </a:defRPr>
-                      </a:pPr>
-                      <a:r>
-                        <a:t>unknown en el 29 % de las filas</a:t>
-                      </a:r>
-                    </a:p>
-                  </a:txBody>
-                  <a:tcPr/>
-                </a:tc>
-              </a:tr>
-              <a:tr h="346165">
-                <a:tc>
-                  <a:txBody>
-                    <a:bodyPr/>
-                    <a:lstStyle/>
-                    <a:p>
-                      <a:pPr>
-                        <a:defRPr sz="1200">
-                          <a:latin typeface="Calibri"/>
-                        </a:defRPr>
-                      </a:pPr>
-                      <a:r>
-                        <a:t>Último contacto</a:t>
-                      </a:r>
-                    </a:p>
-                  </a:txBody>
-                  <a:tcPr/>
-                </a:tc>
-                <a:tc>
-                  <a:txBody>
-                    <a:bodyPr/>
-                    <a:lstStyle/>
-                    <a:p>
-                      <a:pPr>
-                        <a:defRPr sz="1200">
-                          <a:latin typeface="Calibri"/>
-                        </a:defRPr>
-                      </a:pPr>
-                      <a:r>
-                        <a:t>day, month</a:t>
-                      </a:r>
-                    </a:p>
-                  </a:txBody>
-                  <a:tcPr/>
-                </a:tc>
-                <a:tc>
-                  <a:txBody>
-                    <a:bodyPr/>
-                    <a:lstStyle/>
-                    <a:p>
-                      <a:pPr>
-                        <a:defRPr sz="1200">
-                          <a:latin typeface="Calibri"/>
-                        </a:defRPr>
-                      </a:pPr>
-                      <a:r>
-                        <a:t>numérica y categórica</a:t>
-                      </a:r>
-                    </a:p>
-                  </a:txBody>
-                  <a:tcPr/>
-                </a:tc>
-                <a:tc>
-                  <a:txBody>
-                    <a:bodyPr/>
-                    <a:lstStyle/>
-                    <a:p>
-                      <a:pPr>
-                        <a:defRPr sz="1200">
-                          <a:latin typeface="Calibri"/>
-                        </a:defRPr>
-                      </a:pPr>
-                      <a:r>
-                        <a:t>fecha del último contacto sin año</a:t>
-                      </a:r>
-                    </a:p>
-                  </a:txBody>
-                  <a:tcPr/>
-                </a:tc>
-              </a:tr>
-              <a:tr h="346165">
-                <a:tc>
-                  <a:txBody>
-                    <a:bodyPr/>
-                    <a:lstStyle/>
-                    <a:p>
-                      <a:pPr>
-                        <a:defRPr sz="1200">
-                          <a:latin typeface="Calibri"/>
-                        </a:defRPr>
-                      </a:pPr>
-                      <a:r>
-                        <a:t>Último contacto</a:t>
-                      </a:r>
-                    </a:p>
-                  </a:txBody>
-                  <a:tcPr/>
-                </a:tc>
-                <a:tc>
-                  <a:txBody>
-                    <a:bodyPr/>
-                    <a:lstStyle/>
-                    <a:p>
-                      <a:pPr>
-                        <a:defRPr sz="1200">
-                          <a:latin typeface="Calibri"/>
-                        </a:defRPr>
-                      </a:pPr>
-                      <a:r>
-                        <a:t>duration</a:t>
-                      </a:r>
-                    </a:p>
-                  </a:txBody>
-                  <a:tcPr/>
-                </a:tc>
-                <a:tc>
-                  <a:txBody>
-                    <a:bodyPr/>
-                    <a:lstStyle/>
-                    <a:p>
-                      <a:pPr>
-                        <a:defRPr sz="1200">
-                          <a:latin typeface="Calibri"/>
-                        </a:defRPr>
-                      </a:pPr>
-                      <a:r>
-                        <a:t>numérica</a:t>
-                      </a:r>
-                    </a:p>
-                  </a:txBody>
-                  <a:tcPr/>
-                </a:tc>
-                <a:tc>
-                  <a:txBody>
-                    <a:bodyPr/>
-                    <a:lstStyle/>
-                    <a:p>
-                      <a:pPr>
-                        <a:defRPr sz="1200">
-                          <a:latin typeface="Calibri"/>
-                        </a:defRPr>
-                      </a:pPr>
-                      <a:r>
-                        <a:t>segundos de la llamada, se conoce después de llamar</a:t>
-                      </a:r>
-                    </a:p>
-                  </a:txBody>
-                  <a:tcPr/>
-                </a:tc>
-              </a:tr>
-              <a:tr h="346165">
-                <a:tc>
-                  <a:txBody>
-                    <a:bodyPr/>
-                    <a:lstStyle/>
-                    <a:p>
-                      <a:pPr>
-                        <a:defRPr sz="1200">
-                          <a:latin typeface="Calibri"/>
-                        </a:defRPr>
-                      </a:pPr>
-                      <a:r>
-                        <a:t>Campaña</a:t>
-                      </a:r>
-                    </a:p>
-                  </a:txBody>
-                  <a:tcPr/>
-                </a:tc>
-                <a:tc>
-                  <a:txBody>
-                    <a:bodyPr/>
-                    <a:lstStyle/>
-                    <a:p>
-                      <a:pPr>
-                        <a:defRPr sz="1200">
-                          <a:latin typeface="Calibri"/>
-                        </a:defRPr>
-                      </a:pPr>
-                      <a:r>
-                        <a:t>campaign</a:t>
-                      </a:r>
-                    </a:p>
-                  </a:txBody>
-                  <a:tcPr/>
-                </a:tc>
-                <a:tc>
-                  <a:txBody>
-                    <a:bodyPr/>
-                    <a:lstStyle/>
-                    <a:p>
-                      <a:pPr>
-                        <a:defRPr sz="1200">
-                          <a:latin typeface="Calibri"/>
-                        </a:defRPr>
-                      </a:pPr>
-                      <a:r>
-                        <a:t>numérica</a:t>
-                      </a:r>
-                    </a:p>
-                  </a:txBody>
-                  <a:tcPr/>
-                </a:tc>
-                <a:tc>
-                  <a:txBody>
-                    <a:bodyPr/>
-                    <a:lstStyle/>
-                    <a:p>
-                      <a:pPr>
-                        <a:defRPr sz="1200">
-                          <a:latin typeface="Calibri"/>
-                        </a:defRPr>
-                      </a:pPr>
-                      <a:r>
-                        <a:t>contactos en esta campaña</a:t>
-                      </a:r>
-                    </a:p>
-                  </a:txBody>
-                  <a:tcPr/>
-                </a:tc>
-              </a:tr>
-              <a:tr h="346165">
-                <a:tc>
-                  <a:txBody>
-                    <a:bodyPr/>
-                    <a:lstStyle/>
-                    <a:p>
-                      <a:pPr>
-                        <a:defRPr sz="1200">
-                          <a:latin typeface="Calibri"/>
-                        </a:defRPr>
-                      </a:pPr>
-                      <a:r>
-                        <a:t>Campaña</a:t>
-                      </a:r>
-                    </a:p>
-                  </a:txBody>
-                  <a:tcPr/>
-                </a:tc>
-                <a:tc>
-                  <a:txBody>
-                    <a:bodyPr/>
-                    <a:lstStyle/>
-                    <a:p>
-                      <a:pPr>
-                        <a:defRPr sz="1200">
-                          <a:latin typeface="Calibri"/>
-                        </a:defRPr>
-                      </a:pPr>
-                      <a:r>
-                        <a:t>pdays</a:t>
-                      </a:r>
-                    </a:p>
-                  </a:txBody>
-                  <a:tcPr/>
-                </a:tc>
-                <a:tc>
-                  <a:txBody>
-                    <a:bodyPr/>
-                    <a:lstStyle/>
-                    <a:p>
-                      <a:pPr>
-                        <a:defRPr sz="1200">
-                          <a:latin typeface="Calibri"/>
-                        </a:defRPr>
-                      </a:pPr>
-                      <a:r>
-                        <a:t>numérica</a:t>
-                      </a:r>
-                    </a:p>
-                  </a:txBody>
-                  <a:tcPr/>
-                </a:tc>
-                <a:tc>
-                  <a:txBody>
-                    <a:bodyPr/>
-                    <a:lstStyle/>
-                    <a:p>
-                      <a:pPr>
-                        <a:defRPr sz="1200">
-                          <a:latin typeface="Calibri"/>
-                        </a:defRPr>
-                      </a:pPr>
-                      <a:r>
-                        <a:t>días desde la campaña anterior, -1 si nunca</a:t>
-                      </a:r>
-                    </a:p>
-                  </a:txBody>
-                  <a:tcPr/>
-                </a:tc>
-              </a:tr>
-              <a:tr h="346165">
-                <a:tc>
-                  <a:txBody>
-                    <a:bodyPr/>
-                    <a:lstStyle/>
-                    <a:p>
-                      <a:pPr>
-                        <a:defRPr sz="1200">
-                          <a:latin typeface="Calibri"/>
-                        </a:defRPr>
-                      </a:pPr>
-                      <a:r>
-                        <a:t>Campaña</a:t>
-                      </a:r>
-                    </a:p>
-                  </a:txBody>
-                  <a:tcPr/>
-                </a:tc>
-                <a:tc>
-                  <a:txBody>
-                    <a:bodyPr/>
-                    <a:lstStyle/>
-                    <a:p>
-                      <a:pPr>
-                        <a:defRPr sz="1200">
-                          <a:latin typeface="Calibri"/>
-                        </a:defRPr>
-                      </a:pPr>
-                      <a:r>
-                        <a:t>previous</a:t>
-                      </a:r>
-                    </a:p>
-                  </a:txBody>
-                  <a:tcPr/>
-                </a:tc>
-                <a:tc>
-                  <a:txBody>
-                    <a:bodyPr/>
-                    <a:lstStyle/>
-                    <a:p>
-                      <a:pPr>
-                        <a:defRPr sz="1200">
-                          <a:latin typeface="Calibri"/>
-                        </a:defRPr>
-                      </a:pPr>
-                      <a:r>
-                        <a:t>numérica</a:t>
-                      </a:r>
-                    </a:p>
-                  </a:txBody>
-                  <a:tcPr/>
-                </a:tc>
-                <a:tc>
-                  <a:txBody>
-                    <a:bodyPr/>
-                    <a:lstStyle/>
-                    <a:p>
-                      <a:pPr>
-                        <a:defRPr sz="1200">
-                          <a:latin typeface="Calibri"/>
-                        </a:defRPr>
-                      </a:pPr>
-                      <a:r>
-                        <a:t>contactos antes de esta campaña</a:t>
-                      </a:r>
-                    </a:p>
-                  </a:txBody>
-                  <a:tcPr/>
-                </a:tc>
-              </a:tr>
-              <a:tr h="346175">
-                <a:tc>
-                  <a:txBody>
-                    <a:bodyPr/>
-                    <a:lstStyle/>
-                    <a:p>
-                      <a:pPr>
-                        <a:defRPr sz="1200">
-                          <a:latin typeface="Calibri"/>
-                        </a:defRPr>
-                      </a:pPr>
-                      <a:r>
-                        <a:t>Campaña</a:t>
-                      </a:r>
-                    </a:p>
-                  </a:txBody>
-                  <a:tcPr/>
-                </a:tc>
-                <a:tc>
-                  <a:txBody>
-                    <a:bodyPr/>
-                    <a:lstStyle/>
-                    <a:p>
-                      <a:pPr>
-                        <a:defRPr sz="1200">
-                          <a:latin typeface="Calibri"/>
-                        </a:defRPr>
-                      </a:pPr>
-                      <a:r>
-                        <a:t>poutcome</a:t>
-                      </a:r>
-                    </a:p>
-                  </a:txBody>
-                  <a:tcPr/>
-                </a:tc>
-                <a:tc>
-                  <a:txBody>
-                    <a:bodyPr/>
-                    <a:lstStyle/>
-                    <a:p>
-                      <a:pPr>
-                        <a:defRPr sz="1200">
-                          <a:latin typeface="Calibri"/>
-                        </a:defRPr>
-                      </a:pPr>
-                      <a:r>
-                        <a:t>categórica 4 niveles</a:t>
-                      </a:r>
-                    </a:p>
-                  </a:txBody>
-                  <a:tcPr/>
-                </a:tc>
-                <a:tc>
-                  <a:txBody>
-                    <a:bodyPr/>
-                    <a:lstStyle/>
-                    <a:p>
-                      <a:pPr>
-                        <a:defRPr sz="1200">
-                          <a:latin typeface="Calibri"/>
-                        </a:defRPr>
-                      </a:pPr>
-                      <a:r>
-                        <a:t>unknown en el 82 % de las filas</a:t>
-                      </a:r>
-                    </a:p>
-                  </a:txBody>
-                  <a:tcPr/>
-                </a:tc>
-              </a:tr>
-            </a:tbl>
-          </a:graphicData>
-        </a:graphic>
-      </p:graphicFrame>
+        </p:nvSpPr>
+        <p:spPr>
+          <a:xfrm>
+            <a:off x="640080" y="1463040"/>
+            <a:ext cx="10972800" cy="4846320"/>
+          </a:xfrm>
+          <a:prstGeom prst="rect">
+            <a:avLst/>
+          </a:prstGeom>
+          <a:noFill/>
+        </p:spPr>
+        <p:txBody>
+          <a:bodyPr wrap="square">
+            <a:spAutoFit/>
+          </a:bodyPr>
+          <a:lstStyle/>
+          <a:p>
+            <a:pPr>
+              <a:spcAft>
+                <a:spcPts val="600"/>
+              </a:spcAft>
+              <a:defRPr sz="1800">
+                <a:latin typeface="Calibri"/>
+              </a:defRPr>
+            </a:pPr>
+            <a:r>
+              <a:t>• Campañas telefónicas de un banco portugués entre mayo de 2008 y noviembre de 2010</a:t>
+            </a:r>
+          </a:p>
+          <a:p>
+            <a:pPr>
+              <a:spcAft>
+                <a:spcPts val="600"/>
+              </a:spcAft>
+              <a:defRPr sz="1800">
+                <a:latin typeface="Calibri"/>
+              </a:defRPr>
+            </a:pPr>
+            <a:r>
+              <a:t>• Objetivo. Predecir si el cliente suscribe un depósito a plazo (variable y)</a:t>
+            </a:r>
+          </a:p>
+          <a:p>
+            <a:pPr>
+              <a:spcAft>
+                <a:spcPts val="600"/>
+              </a:spcAft>
+              <a:defRPr sz="1800">
+                <a:latin typeface="Calibri"/>
+              </a:defRPr>
+            </a:pPr>
+            <a:r>
+              <a:t>• 45 211 registros, 16 atributos de entrada y la clase</a:t>
+            </a:r>
+          </a:p>
+          <a:p>
+            <a:pPr>
+              <a:spcAft>
+                <a:spcPts val="600"/>
+              </a:spcAft>
+              <a:defRPr sz="1800">
+                <a:latin typeface="Calibri"/>
+              </a:defRPr>
+            </a:pPr>
+            <a:r>
+              <a:t>• Sin valores faltantes explícitos, pero varias categóricas usan la etiqueta unknown</a:t>
+            </a:r>
+          </a:p>
+          <a:p>
+            <a:pPr>
+              <a:spcAft>
+                <a:spcPts val="600"/>
+              </a:spcAft>
+              <a:defRPr sz="1800">
+                <a:latin typeface="Calibri"/>
+              </a:defRPr>
+            </a:pPr>
+            <a:r>
+              <a:t>• Clase muy desbalanceada, 39 922 no frente a 5 289 sí (11.7 % de positivos)</a:t>
+            </a:r>
+          </a:p>
+          <a:p>
+            <a:pPr>
+              <a:spcAft>
+                <a:spcPts val="600"/>
+              </a:spcAft>
+              <a:defRPr sz="1800">
+                <a:latin typeface="Calibri"/>
+              </a:defRPr>
+            </a:pPr>
+            <a:r>
+              <a:t>• Archivo bank-full.csv, separado por punto y coma</a:t>
+            </a:r>
+          </a:p>
+          <a:p>
+            <a:pPr>
+              <a:spcAft>
+                <a:spcPts val="600"/>
+              </a:spcAft>
+              <a:defRPr sz="1800">
+                <a:latin typeface="Calibri"/>
+              </a:defRPr>
+            </a:pPr>
+            <a:r>
+              <a:t>• Plan de trabajo en cuatro pasos sobre el dato</a:t>
+            </a:r>
+          </a:p>
+          <a:p>
+            <a:pPr lvl="1">
+              <a:spcAft>
+                <a:spcPts val="600"/>
+              </a:spcAft>
+              <a:defRPr sz="1600">
+                <a:latin typeface="Calibri"/>
+              </a:defRPr>
+            </a:pPr>
+            <a:r>
+              <a:t>– T0 crudo, tal como viene</a:t>
+            </a:r>
+          </a:p>
+          <a:p>
+            <a:pPr lvl="1">
+              <a:spcAft>
+                <a:spcPts val="600"/>
+              </a:spcAft>
+              <a:defRPr sz="1600">
+                <a:latin typeface="Calibri"/>
+              </a:defRPr>
+            </a:pPr>
+            <a:r>
+              <a:t>– T1 arreglo de columnas, filas, faltantes y atípicos</a:t>
+            </a:r>
+          </a:p>
+          <a:p>
+            <a:pPr lvl="1">
+              <a:spcAft>
+                <a:spcPts val="600"/>
+              </a:spcAft>
+              <a:defRPr sz="1600">
+                <a:latin typeface="Calibri"/>
+              </a:defRPr>
+            </a:pPr>
+            <a:r>
+              <a:t>– T2 codificación, estandarización y normalización</a:t>
+            </a:r>
+          </a:p>
+          <a:p>
+            <a:pPr lvl="1">
+              <a:spcAft>
+                <a:spcPts val="600"/>
+              </a:spcAft>
+              <a:defRPr sz="1600">
+                <a:latin typeface="Calibri"/>
+              </a:defRPr>
+            </a:pPr>
+            <a:r>
+              <a:t>– T3 balanceo de clases, por submuestreo y por sobremuestreo</a:t>
+            </a:r>
+          </a:p>
+        </p:txBody>
+      </p:sp>
     </p:spTree>
   </p:cSld>
   <p:clrMapOvr>
@@ -6748,7 +5972,7 @@
 </p:sld>
 </file>
 
-<file path=ppt/slides/slide4.xml><?xml version="1.0" encoding="utf-8"?>
+<file path=ppt/slides/slide3.xml><?xml version="1.0" encoding="utf-8"?>
 <p:sld xmlns:a="http://schemas.openxmlformats.org/drawingml/2006/main" xmlns:p="http://schemas.openxmlformats.org/presentationml/2006/main" xmlns:r="http://schemas.openxmlformats.org/officeDocument/2006/relationships">
   <p:cSld>
     <p:spTree>
@@ -6789,7 +6013,7 @@
               </a:defRPr>
             </a:pPr>
             <a:r>
-              <a:t>T0. Distribución de las numéricas</a:t>
+              <a:t>Variables</a:t>
             </a:r>
           </a:p>
           <a:p>
@@ -6802,7 +6026,7 @@
               </a:defRPr>
             </a:pPr>
             <a:r>
-              <a:t>Histogramas de las siete variables numéricas y de la clase</a:t>
+              <a:t>Tres grupos según la documentación original</a:t>
             </a:r>
           </a:p>
         </p:txBody>
@@ -6850,131 +6074,1014 @@
           </a:p>
         </p:txBody>
       </p:sp>
-      <p:pic>
-        <p:nvPicPr>
-          <p:cNvPr id="4" name="Picture 3" descr="fig01.png"/>
-          <p:cNvPicPr>
-            <a:picLocks noChangeAspect="1"/>
-          </p:cNvPicPr>
+      <p:graphicFrame>
+        <p:nvGraphicFramePr>
+          <p:cNvPr id="4" name="Table 3"/>
+          <p:cNvGraphicFramePr>
+            <a:graphicFrameLocks noGrp="1"/>
+          </p:cNvGraphicFramePr>
           <p:nvPr/>
-        </p:nvPicPr>
-        <p:blipFill>
-          <a:blip r:embed="rId2"/>
-          <a:stretch>
-            <a:fillRect/>
-          </a:stretch>
-        </p:blipFill>
-        <p:spPr>
-          <a:xfrm>
-            <a:off x="457200" y="1325880"/>
-            <a:ext cx="7863840" cy="4276727"/>
-          </a:xfrm>
-          <a:prstGeom prst="rect">
-            <a:avLst/>
-          </a:prstGeom>
-        </p:spPr>
-      </p:pic>
-      <p:sp>
-        <p:nvSpPr>
-          <p:cNvPr id="5" name="TextBox 4"/>
-          <p:cNvSpPr txBox="1"/>
-          <p:nvPr/>
-        </p:nvSpPr>
-        <p:spPr>
-          <a:xfrm>
-            <a:off x="8503920" y="1463040"/>
-            <a:ext cx="3383280" cy="5029200"/>
-          </a:xfrm>
-          <a:prstGeom prst="rect">
-            <a:avLst/>
-          </a:prstGeom>
-          <a:noFill/>
-        </p:spPr>
-        <p:txBody>
-          <a:bodyPr wrap="square">
-            <a:spAutoFit/>
-          </a:bodyPr>
-          <a:lstStyle/>
-          <a:p>
-            <a:pPr>
-              <a:spcAft>
-                <a:spcPts val="600"/>
-              </a:spcAft>
-              <a:defRPr sz="1600">
-                <a:latin typeface="Calibri"/>
-              </a:defRPr>
-            </a:pPr>
-            <a:r>
-              <a:t>• age es la única con forma razonable</a:t>
-            </a:r>
-          </a:p>
-          <a:p>
-            <a:pPr>
-              <a:spcAft>
-                <a:spcPts val="600"/>
-              </a:spcAft>
-              <a:defRPr sz="1600">
-                <a:latin typeface="Calibri"/>
-              </a:defRPr>
-            </a:pPr>
-            <a:r>
-              <a:t>• balance, campaign y previous tienen colas larguísimas</a:t>
-            </a:r>
-          </a:p>
-          <a:p>
-            <a:pPr>
-              <a:spcAft>
-                <a:spcPts val="600"/>
-              </a:spcAft>
-              <a:defRPr sz="1600">
-                <a:latin typeface="Calibri"/>
-              </a:defRPr>
-            </a:pPr>
-            <a:r>
-              <a:t>• pdays es casi toda -1 (82 % nunca contactados)</a:t>
-            </a:r>
-          </a:p>
-          <a:p>
-            <a:pPr>
-              <a:spcAft>
-                <a:spcPts val="600"/>
-              </a:spcAft>
-              <a:defRPr sz="1600">
-                <a:latin typeface="Calibri"/>
-              </a:defRPr>
-            </a:pPr>
-            <a:r>
-              <a:t>• duration se concentra en llamadas cortas</a:t>
-            </a:r>
-          </a:p>
-          <a:p>
-            <a:pPr>
-              <a:spcAft>
-                <a:spcPts val="600"/>
-              </a:spcAft>
-              <a:defRPr sz="1600">
-                <a:latin typeface="Calibri"/>
-              </a:defRPr>
-            </a:pPr>
-            <a:r>
-              <a:t>• day cubre todo el mes, sin patrón claro</a:t>
-            </a:r>
-          </a:p>
-          <a:p>
-            <a:pPr>
-              <a:spcAft>
-                <a:spcPts val="600"/>
-              </a:spcAft>
-              <a:defRPr sz="1600">
-                <a:latin typeface="Calibri"/>
-              </a:defRPr>
-            </a:pPr>
-            <a:r>
-              <a:t>• y desbalanceada, 7.5 no por cada sí</a:t>
-            </a:r>
-          </a:p>
-        </p:txBody>
-      </p:sp>
+        </p:nvGraphicFramePr>
+        <p:xfrm>
+          <a:off x="457200" y="1371600"/>
+          <a:ext cx="11247120" cy="4846320"/>
+        </p:xfrm>
+        <a:graphic>
+          <a:graphicData uri="http://schemas.openxmlformats.org/drawingml/2006/table">
+            <a:tbl>
+              <a:tblPr firstRow="1" bandRow="1">
+                <a:tableStyleId>{5C22544A-7EE6-4342-B048-85BDC9FD1C3A}</a:tableStyleId>
+              </a:tblPr>
+              <a:tblGrid>
+                <a:gridCol w="2811780"/>
+                <a:gridCol w="2811780"/>
+                <a:gridCol w="2811780"/>
+                <a:gridCol w="2811780"/>
+              </a:tblGrid>
+              <a:tr h="346165">
+                <a:tc>
+                  <a:txBody>
+                    <a:bodyPr/>
+                    <a:lstStyle/>
+                    <a:p>
+                      <a:pPr>
+                        <a:defRPr sz="1200" b="1">
+                          <a:latin typeface="Calibri"/>
+                        </a:defRPr>
+                      </a:pPr>
+                      <a:r>
+                        <a:t>Grupo</a:t>
+                      </a:r>
+                    </a:p>
+                  </a:txBody>
+                  <a:tcPr/>
+                </a:tc>
+                <a:tc>
+                  <a:txBody>
+                    <a:bodyPr/>
+                    <a:lstStyle/>
+                    <a:p>
+                      <a:pPr>
+                        <a:defRPr sz="1200" b="1">
+                          <a:latin typeface="Calibri"/>
+                        </a:defRPr>
+                      </a:pPr>
+                      <a:r>
+                        <a:t>Variable</a:t>
+                      </a:r>
+                    </a:p>
+                  </a:txBody>
+                  <a:tcPr/>
+                </a:tc>
+                <a:tc>
+                  <a:txBody>
+                    <a:bodyPr/>
+                    <a:lstStyle/>
+                    <a:p>
+                      <a:pPr>
+                        <a:defRPr sz="1200" b="1">
+                          <a:latin typeface="Calibri"/>
+                        </a:defRPr>
+                      </a:pPr>
+                      <a:r>
+                        <a:t>Tipo</a:t>
+                      </a:r>
+                    </a:p>
+                  </a:txBody>
+                  <a:tcPr/>
+                </a:tc>
+                <a:tc>
+                  <a:txBody>
+                    <a:bodyPr/>
+                    <a:lstStyle/>
+                    <a:p>
+                      <a:pPr>
+                        <a:defRPr sz="1200" b="1">
+                          <a:latin typeface="Calibri"/>
+                        </a:defRPr>
+                      </a:pPr>
+                      <a:r>
+                        <a:t>Observación</a:t>
+                      </a:r>
+                    </a:p>
+                  </a:txBody>
+                  <a:tcPr/>
+                </a:tc>
+              </a:tr>
+              <a:tr h="346165">
+                <a:tc>
+                  <a:txBody>
+                    <a:bodyPr/>
+                    <a:lstStyle/>
+                    <a:p>
+                      <a:pPr>
+                        <a:defRPr sz="1200">
+                          <a:latin typeface="Calibri"/>
+                        </a:defRPr>
+                      </a:pPr>
+                      <a:r>
+                        <a:t>Cliente</a:t>
+                      </a:r>
+                    </a:p>
+                  </a:txBody>
+                  <a:tcPr/>
+                </a:tc>
+                <a:tc>
+                  <a:txBody>
+                    <a:bodyPr/>
+                    <a:lstStyle/>
+                    <a:p>
+                      <a:pPr>
+                        <a:defRPr sz="1200">
+                          <a:latin typeface="Calibri"/>
+                        </a:defRPr>
+                      </a:pPr>
+                      <a:r>
+                        <a:t>age</a:t>
+                      </a:r>
+                    </a:p>
+                  </a:txBody>
+                  <a:tcPr/>
+                </a:tc>
+                <a:tc>
+                  <a:txBody>
+                    <a:bodyPr/>
+                    <a:lstStyle/>
+                    <a:p>
+                      <a:pPr>
+                        <a:defRPr sz="1200">
+                          <a:latin typeface="Calibri"/>
+                        </a:defRPr>
+                      </a:pPr>
+                      <a:r>
+                        <a:t>numérica</a:t>
+                      </a:r>
+                    </a:p>
+                  </a:txBody>
+                  <a:tcPr/>
+                </a:tc>
+                <a:tc>
+                  <a:txBody>
+                    <a:bodyPr/>
+                    <a:lstStyle/>
+                    <a:p>
+                      <a:pPr>
+                        <a:defRPr sz="1200">
+                          <a:latin typeface="Calibri"/>
+                        </a:defRPr>
+                      </a:pPr>
+                      <a:r>
+                        <a:t>18 a 95 años</a:t>
+                      </a:r>
+                    </a:p>
+                  </a:txBody>
+                  <a:tcPr/>
+                </a:tc>
+              </a:tr>
+              <a:tr h="346165">
+                <a:tc>
+                  <a:txBody>
+                    <a:bodyPr/>
+                    <a:lstStyle/>
+                    <a:p>
+                      <a:pPr>
+                        <a:defRPr sz="1200">
+                          <a:latin typeface="Calibri"/>
+                        </a:defRPr>
+                      </a:pPr>
+                      <a:r>
+                        <a:t>Cliente</a:t>
+                      </a:r>
+                    </a:p>
+                  </a:txBody>
+                  <a:tcPr/>
+                </a:tc>
+                <a:tc>
+                  <a:txBody>
+                    <a:bodyPr/>
+                    <a:lstStyle/>
+                    <a:p>
+                      <a:pPr>
+                        <a:defRPr sz="1200">
+                          <a:latin typeface="Calibri"/>
+                        </a:defRPr>
+                      </a:pPr>
+                      <a:r>
+                        <a:t>job</a:t>
+                      </a:r>
+                    </a:p>
+                  </a:txBody>
+                  <a:tcPr/>
+                </a:tc>
+                <a:tc>
+                  <a:txBody>
+                    <a:bodyPr/>
+                    <a:lstStyle/>
+                    <a:p>
+                      <a:pPr>
+                        <a:defRPr sz="1200">
+                          <a:latin typeface="Calibri"/>
+                        </a:defRPr>
+                      </a:pPr>
+                      <a:r>
+                        <a:t>categórica 12 niveles</a:t>
+                      </a:r>
+                    </a:p>
+                  </a:txBody>
+                  <a:tcPr/>
+                </a:tc>
+                <a:tc>
+                  <a:txBody>
+                    <a:bodyPr/>
+                    <a:lstStyle/>
+                    <a:p>
+                      <a:pPr>
+                        <a:defRPr sz="1200">
+                          <a:latin typeface="Calibri"/>
+                        </a:defRPr>
+                      </a:pPr>
+                      <a:r>
+                        <a:t>incluye unknown (288), quedan 11 niveles</a:t>
+                      </a:r>
+                    </a:p>
+                  </a:txBody>
+                  <a:tcPr/>
+                </a:tc>
+              </a:tr>
+              <a:tr h="346165">
+                <a:tc>
+                  <a:txBody>
+                    <a:bodyPr/>
+                    <a:lstStyle/>
+                    <a:p>
+                      <a:pPr>
+                        <a:defRPr sz="1200">
+                          <a:latin typeface="Calibri"/>
+                        </a:defRPr>
+                      </a:pPr>
+                      <a:r>
+                        <a:t>Cliente</a:t>
+                      </a:r>
+                    </a:p>
+                  </a:txBody>
+                  <a:tcPr/>
+                </a:tc>
+                <a:tc>
+                  <a:txBody>
+                    <a:bodyPr/>
+                    <a:lstStyle/>
+                    <a:p>
+                      <a:pPr>
+                        <a:defRPr sz="1200">
+                          <a:latin typeface="Calibri"/>
+                        </a:defRPr>
+                      </a:pPr>
+                      <a:r>
+                        <a:t>marital</a:t>
+                      </a:r>
+                    </a:p>
+                  </a:txBody>
+                  <a:tcPr/>
+                </a:tc>
+                <a:tc>
+                  <a:txBody>
+                    <a:bodyPr/>
+                    <a:lstStyle/>
+                    <a:p>
+                      <a:pPr>
+                        <a:defRPr sz="1200">
+                          <a:latin typeface="Calibri"/>
+                        </a:defRPr>
+                      </a:pPr>
+                      <a:r>
+                        <a:t>categórica 3 niveles</a:t>
+                      </a:r>
+                    </a:p>
+                  </a:txBody>
+                  <a:tcPr/>
+                </a:tc>
+                <a:tc>
+                  <a:txBody>
+                    <a:bodyPr/>
+                    <a:lstStyle/>
+                    <a:p>
+                      <a:pPr>
+                        <a:defRPr sz="1200">
+                          <a:latin typeface="Calibri"/>
+                        </a:defRPr>
+                      </a:pPr>
+                      <a:r>
+                        <a:t>divorced agrupa divorciados y viudos</a:t>
+                      </a:r>
+                    </a:p>
+                  </a:txBody>
+                  <a:tcPr/>
+                </a:tc>
+              </a:tr>
+              <a:tr h="346165">
+                <a:tc>
+                  <a:txBody>
+                    <a:bodyPr/>
+                    <a:lstStyle/>
+                    <a:p>
+                      <a:pPr>
+                        <a:defRPr sz="1200">
+                          <a:latin typeface="Calibri"/>
+                        </a:defRPr>
+                      </a:pPr>
+                      <a:r>
+                        <a:t>Cliente</a:t>
+                      </a:r>
+                    </a:p>
+                  </a:txBody>
+                  <a:tcPr/>
+                </a:tc>
+                <a:tc>
+                  <a:txBody>
+                    <a:bodyPr/>
+                    <a:lstStyle/>
+                    <a:p>
+                      <a:pPr>
+                        <a:defRPr sz="1200">
+                          <a:latin typeface="Calibri"/>
+                        </a:defRPr>
+                      </a:pPr>
+                      <a:r>
+                        <a:t>education</a:t>
+                      </a:r>
+                    </a:p>
+                  </a:txBody>
+                  <a:tcPr/>
+                </a:tc>
+                <a:tc>
+                  <a:txBody>
+                    <a:bodyPr/>
+                    <a:lstStyle/>
+                    <a:p>
+                      <a:pPr>
+                        <a:defRPr sz="1200">
+                          <a:latin typeface="Calibri"/>
+                        </a:defRPr>
+                      </a:pPr>
+                      <a:r>
+                        <a:t>categórica ordinal</a:t>
+                      </a:r>
+                    </a:p>
+                  </a:txBody>
+                  <a:tcPr/>
+                </a:tc>
+                <a:tc>
+                  <a:txBody>
+                    <a:bodyPr/>
+                    <a:lstStyle/>
+                    <a:p>
+                      <a:pPr>
+                        <a:defRPr sz="1200">
+                          <a:latin typeface="Calibri"/>
+                        </a:defRPr>
+                      </a:pPr>
+                      <a:r>
+                        <a:t>primary, secondary, tertiary, unknown (1 857)</a:t>
+                      </a:r>
+                    </a:p>
+                  </a:txBody>
+                  <a:tcPr/>
+                </a:tc>
+              </a:tr>
+              <a:tr h="346165">
+                <a:tc>
+                  <a:txBody>
+                    <a:bodyPr/>
+                    <a:lstStyle/>
+                    <a:p>
+                      <a:pPr>
+                        <a:defRPr sz="1200">
+                          <a:latin typeface="Calibri"/>
+                        </a:defRPr>
+                      </a:pPr>
+                      <a:r>
+                        <a:t>Cliente</a:t>
+                      </a:r>
+                    </a:p>
+                  </a:txBody>
+                  <a:tcPr/>
+                </a:tc>
+                <a:tc>
+                  <a:txBody>
+                    <a:bodyPr/>
+                    <a:lstStyle/>
+                    <a:p>
+                      <a:pPr>
+                        <a:defRPr sz="1200">
+                          <a:latin typeface="Calibri"/>
+                        </a:defRPr>
+                      </a:pPr>
+                      <a:r>
+                        <a:t>default, housing, loan</a:t>
+                      </a:r>
+                    </a:p>
+                  </a:txBody>
+                  <a:tcPr/>
+                </a:tc>
+                <a:tc>
+                  <a:txBody>
+                    <a:bodyPr/>
+                    <a:lstStyle/>
+                    <a:p>
+                      <a:pPr>
+                        <a:defRPr sz="1200">
+                          <a:latin typeface="Calibri"/>
+                        </a:defRPr>
+                      </a:pPr>
+                      <a:r>
+                        <a:t>binarias yes/no</a:t>
+                      </a:r>
+                    </a:p>
+                  </a:txBody>
+                  <a:tcPr/>
+                </a:tc>
+                <a:tc>
+                  <a:txBody>
+                    <a:bodyPr/>
+                    <a:lstStyle/>
+                    <a:p>
+                      <a:pPr>
+                        <a:defRPr sz="1200">
+                          <a:latin typeface="Calibri"/>
+                        </a:defRPr>
+                      </a:pPr>
+                      <a:r>
+                        <a:t>crédito en mora, hipoteca, préstamo personal</a:t>
+                      </a:r>
+                    </a:p>
+                  </a:txBody>
+                  <a:tcPr/>
+                </a:tc>
+              </a:tr>
+              <a:tr h="346165">
+                <a:tc>
+                  <a:txBody>
+                    <a:bodyPr/>
+                    <a:lstStyle/>
+                    <a:p>
+                      <a:pPr>
+                        <a:defRPr sz="1200">
+                          <a:latin typeface="Calibri"/>
+                        </a:defRPr>
+                      </a:pPr>
+                      <a:r>
+                        <a:t>Cliente</a:t>
+                      </a:r>
+                    </a:p>
+                  </a:txBody>
+                  <a:tcPr/>
+                </a:tc>
+                <a:tc>
+                  <a:txBody>
+                    <a:bodyPr/>
+                    <a:lstStyle/>
+                    <a:p>
+                      <a:pPr>
+                        <a:defRPr sz="1200">
+                          <a:latin typeface="Calibri"/>
+                        </a:defRPr>
+                      </a:pPr>
+                      <a:r>
+                        <a:t>balance</a:t>
+                      </a:r>
+                    </a:p>
+                  </a:txBody>
+                  <a:tcPr/>
+                </a:tc>
+                <a:tc>
+                  <a:txBody>
+                    <a:bodyPr/>
+                    <a:lstStyle/>
+                    <a:p>
+                      <a:pPr>
+                        <a:defRPr sz="1200">
+                          <a:latin typeface="Calibri"/>
+                        </a:defRPr>
+                      </a:pPr>
+                      <a:r>
+                        <a:t>numérica</a:t>
+                      </a:r>
+                    </a:p>
+                  </a:txBody>
+                  <a:tcPr/>
+                </a:tc>
+                <a:tc>
+                  <a:txBody>
+                    <a:bodyPr/>
+                    <a:lstStyle/>
+                    <a:p>
+                      <a:pPr>
+                        <a:defRPr sz="1200">
+                          <a:latin typeface="Calibri"/>
+                        </a:defRPr>
+                      </a:pPr>
+                      <a:r>
+                        <a:t>saldo medio anual en euros, cola muy larga</a:t>
+                      </a:r>
+                    </a:p>
+                  </a:txBody>
+                  <a:tcPr/>
+                </a:tc>
+              </a:tr>
+              <a:tr h="346165">
+                <a:tc>
+                  <a:txBody>
+                    <a:bodyPr/>
+                    <a:lstStyle/>
+                    <a:p>
+                      <a:pPr>
+                        <a:defRPr sz="1200">
+                          <a:latin typeface="Calibri"/>
+                        </a:defRPr>
+                      </a:pPr>
+                      <a:r>
+                        <a:t>Último contacto</a:t>
+                      </a:r>
+                    </a:p>
+                  </a:txBody>
+                  <a:tcPr/>
+                </a:tc>
+                <a:tc>
+                  <a:txBody>
+                    <a:bodyPr/>
+                    <a:lstStyle/>
+                    <a:p>
+                      <a:pPr>
+                        <a:defRPr sz="1200">
+                          <a:latin typeface="Calibri"/>
+                        </a:defRPr>
+                      </a:pPr>
+                      <a:r>
+                        <a:t>contact</a:t>
+                      </a:r>
+                    </a:p>
+                  </a:txBody>
+                  <a:tcPr/>
+                </a:tc>
+                <a:tc>
+                  <a:txBody>
+                    <a:bodyPr/>
+                    <a:lstStyle/>
+                    <a:p>
+                      <a:pPr>
+                        <a:defRPr sz="1200">
+                          <a:latin typeface="Calibri"/>
+                        </a:defRPr>
+                      </a:pPr>
+                      <a:r>
+                        <a:t>categórica 3 niveles</a:t>
+                      </a:r>
+                    </a:p>
+                  </a:txBody>
+                  <a:tcPr/>
+                </a:tc>
+                <a:tc>
+                  <a:txBody>
+                    <a:bodyPr/>
+                    <a:lstStyle/>
+                    <a:p>
+                      <a:pPr>
+                        <a:defRPr sz="1200">
+                          <a:latin typeface="Calibri"/>
+                        </a:defRPr>
+                      </a:pPr>
+                      <a:r>
+                        <a:t>unknown en el 29 % de las filas</a:t>
+                      </a:r>
+                    </a:p>
+                  </a:txBody>
+                  <a:tcPr/>
+                </a:tc>
+              </a:tr>
+              <a:tr h="346165">
+                <a:tc>
+                  <a:txBody>
+                    <a:bodyPr/>
+                    <a:lstStyle/>
+                    <a:p>
+                      <a:pPr>
+                        <a:defRPr sz="1200">
+                          <a:latin typeface="Calibri"/>
+                        </a:defRPr>
+                      </a:pPr>
+                      <a:r>
+                        <a:t>Último contacto</a:t>
+                      </a:r>
+                    </a:p>
+                  </a:txBody>
+                  <a:tcPr/>
+                </a:tc>
+                <a:tc>
+                  <a:txBody>
+                    <a:bodyPr/>
+                    <a:lstStyle/>
+                    <a:p>
+                      <a:pPr>
+                        <a:defRPr sz="1200">
+                          <a:latin typeface="Calibri"/>
+                        </a:defRPr>
+                      </a:pPr>
+                      <a:r>
+                        <a:t>day, month</a:t>
+                      </a:r>
+                    </a:p>
+                  </a:txBody>
+                  <a:tcPr/>
+                </a:tc>
+                <a:tc>
+                  <a:txBody>
+                    <a:bodyPr/>
+                    <a:lstStyle/>
+                    <a:p>
+                      <a:pPr>
+                        <a:defRPr sz="1200">
+                          <a:latin typeface="Calibri"/>
+                        </a:defRPr>
+                      </a:pPr>
+                      <a:r>
+                        <a:t>numérica y categórica</a:t>
+                      </a:r>
+                    </a:p>
+                  </a:txBody>
+                  <a:tcPr/>
+                </a:tc>
+                <a:tc>
+                  <a:txBody>
+                    <a:bodyPr/>
+                    <a:lstStyle/>
+                    <a:p>
+                      <a:pPr>
+                        <a:defRPr sz="1200">
+                          <a:latin typeface="Calibri"/>
+                        </a:defRPr>
+                      </a:pPr>
+                      <a:r>
+                        <a:t>fecha del último contacto sin año</a:t>
+                      </a:r>
+                    </a:p>
+                  </a:txBody>
+                  <a:tcPr/>
+                </a:tc>
+              </a:tr>
+              <a:tr h="346165">
+                <a:tc>
+                  <a:txBody>
+                    <a:bodyPr/>
+                    <a:lstStyle/>
+                    <a:p>
+                      <a:pPr>
+                        <a:defRPr sz="1200">
+                          <a:latin typeface="Calibri"/>
+                        </a:defRPr>
+                      </a:pPr>
+                      <a:r>
+                        <a:t>Último contacto</a:t>
+                      </a:r>
+                    </a:p>
+                  </a:txBody>
+                  <a:tcPr/>
+                </a:tc>
+                <a:tc>
+                  <a:txBody>
+                    <a:bodyPr/>
+                    <a:lstStyle/>
+                    <a:p>
+                      <a:pPr>
+                        <a:defRPr sz="1200">
+                          <a:latin typeface="Calibri"/>
+                        </a:defRPr>
+                      </a:pPr>
+                      <a:r>
+                        <a:t>duration</a:t>
+                      </a:r>
+                    </a:p>
+                  </a:txBody>
+                  <a:tcPr/>
+                </a:tc>
+                <a:tc>
+                  <a:txBody>
+                    <a:bodyPr/>
+                    <a:lstStyle/>
+                    <a:p>
+                      <a:pPr>
+                        <a:defRPr sz="1200">
+                          <a:latin typeface="Calibri"/>
+                        </a:defRPr>
+                      </a:pPr>
+                      <a:r>
+                        <a:t>numérica</a:t>
+                      </a:r>
+                    </a:p>
+                  </a:txBody>
+                  <a:tcPr/>
+                </a:tc>
+                <a:tc>
+                  <a:txBody>
+                    <a:bodyPr/>
+                    <a:lstStyle/>
+                    <a:p>
+                      <a:pPr>
+                        <a:defRPr sz="1200">
+                          <a:latin typeface="Calibri"/>
+                        </a:defRPr>
+                      </a:pPr>
+                      <a:r>
+                        <a:t>segundos de la llamada, se conoce después de llamar</a:t>
+                      </a:r>
+                    </a:p>
+                  </a:txBody>
+                  <a:tcPr/>
+                </a:tc>
+              </a:tr>
+              <a:tr h="346165">
+                <a:tc>
+                  <a:txBody>
+                    <a:bodyPr/>
+                    <a:lstStyle/>
+                    <a:p>
+                      <a:pPr>
+                        <a:defRPr sz="1200">
+                          <a:latin typeface="Calibri"/>
+                        </a:defRPr>
+                      </a:pPr>
+                      <a:r>
+                        <a:t>Campaña</a:t>
+                      </a:r>
+                    </a:p>
+                  </a:txBody>
+                  <a:tcPr/>
+                </a:tc>
+                <a:tc>
+                  <a:txBody>
+                    <a:bodyPr/>
+                    <a:lstStyle/>
+                    <a:p>
+                      <a:pPr>
+                        <a:defRPr sz="1200">
+                          <a:latin typeface="Calibri"/>
+                        </a:defRPr>
+                      </a:pPr>
+                      <a:r>
+                        <a:t>campaign</a:t>
+                      </a:r>
+                    </a:p>
+                  </a:txBody>
+                  <a:tcPr/>
+                </a:tc>
+                <a:tc>
+                  <a:txBody>
+                    <a:bodyPr/>
+                    <a:lstStyle/>
+                    <a:p>
+                      <a:pPr>
+                        <a:defRPr sz="1200">
+                          <a:latin typeface="Calibri"/>
+                        </a:defRPr>
+                      </a:pPr>
+                      <a:r>
+                        <a:t>numérica</a:t>
+                      </a:r>
+                    </a:p>
+                  </a:txBody>
+                  <a:tcPr/>
+                </a:tc>
+                <a:tc>
+                  <a:txBody>
+                    <a:bodyPr/>
+                    <a:lstStyle/>
+                    <a:p>
+                      <a:pPr>
+                        <a:defRPr sz="1200">
+                          <a:latin typeface="Calibri"/>
+                        </a:defRPr>
+                      </a:pPr>
+                      <a:r>
+                        <a:t>contactos en esta campaña</a:t>
+                      </a:r>
+                    </a:p>
+                  </a:txBody>
+                  <a:tcPr/>
+                </a:tc>
+              </a:tr>
+              <a:tr h="346165">
+                <a:tc>
+                  <a:txBody>
+                    <a:bodyPr/>
+                    <a:lstStyle/>
+                    <a:p>
+                      <a:pPr>
+                        <a:defRPr sz="1200">
+                          <a:latin typeface="Calibri"/>
+                        </a:defRPr>
+                      </a:pPr>
+                      <a:r>
+                        <a:t>Campaña</a:t>
+                      </a:r>
+                    </a:p>
+                  </a:txBody>
+                  <a:tcPr/>
+                </a:tc>
+                <a:tc>
+                  <a:txBody>
+                    <a:bodyPr/>
+                    <a:lstStyle/>
+                    <a:p>
+                      <a:pPr>
+                        <a:defRPr sz="1200">
+                          <a:latin typeface="Calibri"/>
+                        </a:defRPr>
+                      </a:pPr>
+                      <a:r>
+                        <a:t>pdays</a:t>
+                      </a:r>
+                    </a:p>
+                  </a:txBody>
+                  <a:tcPr/>
+                </a:tc>
+                <a:tc>
+                  <a:txBody>
+                    <a:bodyPr/>
+                    <a:lstStyle/>
+                    <a:p>
+                      <a:pPr>
+                        <a:defRPr sz="1200">
+                          <a:latin typeface="Calibri"/>
+                        </a:defRPr>
+                      </a:pPr>
+                      <a:r>
+                        <a:t>numérica</a:t>
+                      </a:r>
+                    </a:p>
+                  </a:txBody>
+                  <a:tcPr/>
+                </a:tc>
+                <a:tc>
+                  <a:txBody>
+                    <a:bodyPr/>
+                    <a:lstStyle/>
+                    <a:p>
+                      <a:pPr>
+                        <a:defRPr sz="1200">
+                          <a:latin typeface="Calibri"/>
+                        </a:defRPr>
+                      </a:pPr>
+                      <a:r>
+                        <a:t>días desde la campaña anterior, -1 si nunca</a:t>
+                      </a:r>
+                    </a:p>
+                  </a:txBody>
+                  <a:tcPr/>
+                </a:tc>
+              </a:tr>
+              <a:tr h="346165">
+                <a:tc>
+                  <a:txBody>
+                    <a:bodyPr/>
+                    <a:lstStyle/>
+                    <a:p>
+                      <a:pPr>
+                        <a:defRPr sz="1200">
+                          <a:latin typeface="Calibri"/>
+                        </a:defRPr>
+                      </a:pPr>
+                      <a:r>
+                        <a:t>Campaña</a:t>
+                      </a:r>
+                    </a:p>
+                  </a:txBody>
+                  <a:tcPr/>
+                </a:tc>
+                <a:tc>
+                  <a:txBody>
+                    <a:bodyPr/>
+                    <a:lstStyle/>
+                    <a:p>
+                      <a:pPr>
+                        <a:defRPr sz="1200">
+                          <a:latin typeface="Calibri"/>
+                        </a:defRPr>
+                      </a:pPr>
+                      <a:r>
+                        <a:t>previous</a:t>
+                      </a:r>
+                    </a:p>
+                  </a:txBody>
+                  <a:tcPr/>
+                </a:tc>
+                <a:tc>
+                  <a:txBody>
+                    <a:bodyPr/>
+                    <a:lstStyle/>
+                    <a:p>
+                      <a:pPr>
+                        <a:defRPr sz="1200">
+                          <a:latin typeface="Calibri"/>
+                        </a:defRPr>
+                      </a:pPr>
+                      <a:r>
+                        <a:t>numérica</a:t>
+                      </a:r>
+                    </a:p>
+                  </a:txBody>
+                  <a:tcPr/>
+                </a:tc>
+                <a:tc>
+                  <a:txBody>
+                    <a:bodyPr/>
+                    <a:lstStyle/>
+                    <a:p>
+                      <a:pPr>
+                        <a:defRPr sz="1200">
+                          <a:latin typeface="Calibri"/>
+                        </a:defRPr>
+                      </a:pPr>
+                      <a:r>
+                        <a:t>contactos antes de esta campaña</a:t>
+                      </a:r>
+                    </a:p>
+                  </a:txBody>
+                  <a:tcPr/>
+                </a:tc>
+              </a:tr>
+              <a:tr h="346175">
+                <a:tc>
+                  <a:txBody>
+                    <a:bodyPr/>
+                    <a:lstStyle/>
+                    <a:p>
+                      <a:pPr>
+                        <a:defRPr sz="1200">
+                          <a:latin typeface="Calibri"/>
+                        </a:defRPr>
+                      </a:pPr>
+                      <a:r>
+                        <a:t>Campaña</a:t>
+                      </a:r>
+                    </a:p>
+                  </a:txBody>
+                  <a:tcPr/>
+                </a:tc>
+                <a:tc>
+                  <a:txBody>
+                    <a:bodyPr/>
+                    <a:lstStyle/>
+                    <a:p>
+                      <a:pPr>
+                        <a:defRPr sz="1200">
+                          <a:latin typeface="Calibri"/>
+                        </a:defRPr>
+                      </a:pPr>
+                      <a:r>
+                        <a:t>poutcome</a:t>
+                      </a:r>
+                    </a:p>
+                  </a:txBody>
+                  <a:tcPr/>
+                </a:tc>
+                <a:tc>
+                  <a:txBody>
+                    <a:bodyPr/>
+                    <a:lstStyle/>
+                    <a:p>
+                      <a:pPr>
+                        <a:defRPr sz="1200">
+                          <a:latin typeface="Calibri"/>
+                        </a:defRPr>
+                      </a:pPr>
+                      <a:r>
+                        <a:t>categórica 4 niveles</a:t>
+                      </a:r>
+                    </a:p>
+                  </a:txBody>
+                  <a:tcPr/>
+                </a:tc>
+                <a:tc>
+                  <a:txBody>
+                    <a:bodyPr/>
+                    <a:lstStyle/>
+                    <a:p>
+                      <a:pPr>
+                        <a:defRPr sz="1200">
+                          <a:latin typeface="Calibri"/>
+                        </a:defRPr>
+                      </a:pPr>
+                      <a:r>
+                        <a:t>unknown en el 82 % de las filas</a:t>
+                      </a:r>
+                    </a:p>
+                  </a:txBody>
+                  <a:tcPr/>
+                </a:tc>
+              </a:tr>
+            </a:tbl>
+          </a:graphicData>
+        </a:graphic>
+      </p:graphicFrame>
     </p:spTree>
   </p:cSld>
   <p:clrMapOvr>
@@ -6983,7 +7090,7 @@
 </p:sld>
 </file>
 
-<file path=ppt/slides/slide5.xml><?xml version="1.0" encoding="utf-8"?>
+<file path=ppt/slides/slide4.xml><?xml version="1.0" encoding="utf-8"?>
 <p:sld xmlns:a="http://schemas.openxmlformats.org/drawingml/2006/main" xmlns:p="http://schemas.openxmlformats.org/presentationml/2006/main" xmlns:r="http://schemas.openxmlformats.org/officeDocument/2006/relationships">
   <p:cSld>
     <p:spTree>
@@ -7024,7 +7131,7 @@
               </a:defRPr>
             </a:pPr>
             <a:r>
-              <a:t>T0. Diagramas de caja</a:t>
+              <a:t>T0. Distribución de las numéricas</a:t>
             </a:r>
           </a:p>
           <a:p>
@@ -7037,7 +7144,7 @@
               </a:defRPr>
             </a:pPr>
             <a:r>
-              <a:t>Cada variable en su propia escala</a:t>
+              <a:t>Histogramas de las siete variables numéricas y de la clase</a:t>
             </a:r>
           </a:p>
         </p:txBody>
@@ -7087,6 +7194,241 @@
       </p:sp>
       <p:pic>
         <p:nvPicPr>
+          <p:cNvPr id="4" name="Picture 3" descr="fig01.png"/>
+          <p:cNvPicPr>
+            <a:picLocks noChangeAspect="1"/>
+          </p:cNvPicPr>
+          <p:nvPr/>
+        </p:nvPicPr>
+        <p:blipFill>
+          <a:blip r:embed="rId2"/>
+          <a:stretch>
+            <a:fillRect/>
+          </a:stretch>
+        </p:blipFill>
+        <p:spPr>
+          <a:xfrm>
+            <a:off x="457200" y="1325880"/>
+            <a:ext cx="7863840" cy="5095685"/>
+          </a:xfrm>
+          <a:prstGeom prst="rect">
+            <a:avLst/>
+          </a:prstGeom>
+        </p:spPr>
+      </p:pic>
+      <p:sp>
+        <p:nvSpPr>
+          <p:cNvPr id="5" name="TextBox 4"/>
+          <p:cNvSpPr txBox="1"/>
+          <p:nvPr/>
+        </p:nvSpPr>
+        <p:spPr>
+          <a:xfrm>
+            <a:off x="8503920" y="1463040"/>
+            <a:ext cx="3383280" cy="5029200"/>
+          </a:xfrm>
+          <a:prstGeom prst="rect">
+            <a:avLst/>
+          </a:prstGeom>
+          <a:noFill/>
+        </p:spPr>
+        <p:txBody>
+          <a:bodyPr wrap="square">
+            <a:spAutoFit/>
+          </a:bodyPr>
+          <a:lstStyle/>
+          <a:p>
+            <a:pPr>
+              <a:spcAft>
+                <a:spcPts val="600"/>
+              </a:spcAft>
+              <a:defRPr sz="1600">
+                <a:latin typeface="Calibri"/>
+              </a:defRPr>
+            </a:pPr>
+            <a:r>
+              <a:t>• age es la única con una distribución aproximadamente simétrica</a:t>
+            </a:r>
+          </a:p>
+          <a:p>
+            <a:pPr>
+              <a:spcAft>
+                <a:spcPts val="600"/>
+              </a:spcAft>
+              <a:defRPr sz="1600">
+                <a:latin typeface="Calibri"/>
+              </a:defRPr>
+            </a:pPr>
+            <a:r>
+              <a:t>• balance, campaign y previous presentan colas muy pronunciadas</a:t>
+            </a:r>
+          </a:p>
+          <a:p>
+            <a:pPr>
+              <a:spcAft>
+                <a:spcPts val="600"/>
+              </a:spcAft>
+              <a:defRPr sz="1600">
+                <a:latin typeface="Calibri"/>
+              </a:defRPr>
+            </a:pPr>
+            <a:r>
+              <a:t>• pdays es casi toda -1 (82 % nunca contactados)</a:t>
+            </a:r>
+          </a:p>
+          <a:p>
+            <a:pPr>
+              <a:spcAft>
+                <a:spcPts val="600"/>
+              </a:spcAft>
+              <a:defRPr sz="1600">
+                <a:latin typeface="Calibri"/>
+              </a:defRPr>
+            </a:pPr>
+            <a:r>
+              <a:t>• duration se concentra en llamadas cortas</a:t>
+            </a:r>
+          </a:p>
+          <a:p>
+            <a:pPr>
+              <a:spcAft>
+                <a:spcPts val="600"/>
+              </a:spcAft>
+              <a:defRPr sz="1600">
+                <a:latin typeface="Calibri"/>
+              </a:defRPr>
+            </a:pPr>
+            <a:r>
+              <a:t>• day cubre todo el mes de forma casi uniforme</a:t>
+            </a:r>
+          </a:p>
+          <a:p>
+            <a:pPr>
+              <a:spcAft>
+                <a:spcPts val="600"/>
+              </a:spcAft>
+              <a:defRPr sz="1600">
+                <a:latin typeface="Calibri"/>
+              </a:defRPr>
+            </a:pPr>
+            <a:r>
+              <a:t>• y desbalanceada, 7.5 no por cada sí</a:t>
+            </a:r>
+          </a:p>
+        </p:txBody>
+      </p:sp>
+    </p:spTree>
+  </p:cSld>
+  <p:clrMapOvr>
+    <a:masterClrMapping/>
+  </p:clrMapOvr>
+</p:sld>
+</file>
+
+<file path=ppt/slides/slide5.xml><?xml version="1.0" encoding="utf-8"?>
+<p:sld xmlns:a="http://schemas.openxmlformats.org/drawingml/2006/main" xmlns:p="http://schemas.openxmlformats.org/presentationml/2006/main" xmlns:r="http://schemas.openxmlformats.org/officeDocument/2006/relationships">
+  <p:cSld>
+    <p:spTree>
+      <p:nvGrpSpPr>
+        <p:cNvPr id="1" name=""/>
+        <p:cNvGrpSpPr/>
+        <p:nvPr/>
+      </p:nvGrpSpPr>
+      <p:grpSpPr/>
+      <p:sp>
+        <p:nvSpPr>
+          <p:cNvPr id="2" name="TextBox 1"/>
+          <p:cNvSpPr txBox="1"/>
+          <p:nvPr/>
+        </p:nvSpPr>
+        <p:spPr>
+          <a:xfrm>
+            <a:off x="457200" y="274320"/>
+            <a:ext cx="11247120" cy="822960"/>
+          </a:xfrm>
+          <a:prstGeom prst="rect">
+            <a:avLst/>
+          </a:prstGeom>
+          <a:noFill/>
+        </p:spPr>
+        <p:txBody>
+          <a:bodyPr wrap="none">
+            <a:spAutoFit/>
+          </a:bodyPr>
+          <a:lstStyle/>
+          <a:p>
+            <a:pPr>
+              <a:defRPr sz="3000" b="1">
+                <a:solidFill>
+                  <a:srgbClr val="1F3A5F"/>
+                </a:solidFill>
+                <a:latin typeface="Calibri"/>
+              </a:defRPr>
+            </a:pPr>
+            <a:r>
+              <a:t>T0. Diagramas de caja</a:t>
+            </a:r>
+          </a:p>
+          <a:p>
+            <a:pPr>
+              <a:defRPr sz="1600">
+                <a:solidFill>
+                  <a:srgbClr val="555555"/>
+                </a:solidFill>
+                <a:latin typeface="Calibri"/>
+              </a:defRPr>
+            </a:pPr>
+            <a:r>
+              <a:t>Cada variable en su propia escala</a:t>
+            </a:r>
+          </a:p>
+        </p:txBody>
+      </p:sp>
+      <p:sp>
+        <p:nvSpPr>
+          <p:cNvPr id="3" name="Rectangle 2"/>
+          <p:cNvSpPr/>
+          <p:nvPr/>
+        </p:nvSpPr>
+        <p:spPr>
+          <a:xfrm>
+            <a:off x="457200" y="1143000"/>
+            <a:ext cx="11247120" cy="36576"/>
+          </a:xfrm>
+          <a:prstGeom prst="rect">
+            <a:avLst/>
+          </a:prstGeom>
+          <a:solidFill>
+            <a:srgbClr val="1F3A5F"/>
+          </a:solidFill>
+          <a:ln>
+            <a:noFill/>
+          </a:ln>
+        </p:spPr>
+        <p:style>
+          <a:lnRef idx="1">
+            <a:schemeClr val="accent1"/>
+          </a:lnRef>
+          <a:fillRef idx="3">
+            <a:schemeClr val="accent1"/>
+          </a:fillRef>
+          <a:effectRef idx="2">
+            <a:schemeClr val="accent1"/>
+          </a:effectRef>
+          <a:fontRef idx="minor">
+            <a:schemeClr val="lt1"/>
+          </a:fontRef>
+        </p:style>
+        <p:txBody>
+          <a:bodyPr rtlCol="0" anchor="ctr"/>
+          <a:lstStyle/>
+          <a:p>
+            <a:pPr algn="ctr"/>
+          </a:p>
+        </p:txBody>
+      </p:sp>
+      <p:pic>
+        <p:nvPicPr>
           <p:cNvPr id="4" name="Picture 3" descr="fig02.png"/>
           <p:cNvPicPr>
             <a:picLocks noChangeAspect="1"/>
@@ -7102,7 +7444,7 @@
         <p:spPr>
           <a:xfrm>
             <a:off x="457200" y="1325880"/>
-            <a:ext cx="7863840" cy="5147815"/>
+            <a:ext cx="7863840" cy="5142350"/>
           </a:xfrm>
           <a:prstGeom prst="rect">
             <a:avLst/>
@@ -7680,7 +8022,7 @@
               </a:defRPr>
             </a:pPr>
             <a:r>
-              <a:t>• Las unknown de poutcome son exactamente las filas con previous igual a cero</a:t>
+              <a:t>• Las unknown de poutcome coinciden con las filas de previous igual a cero salvo cinco casos</a:t>
             </a:r>
           </a:p>
         </p:txBody>
@@ -7747,7 +8089,7 @@
               </a:defRPr>
             </a:pPr>
             <a:r>
-              <a:t>Menos columnas y con significado, sin tocar mucho el dato</a:t>
+              <a:t>Menos columnas y con significado, con intervención mínima sobre el dato</a:t>
             </a:r>
           </a:p>
         </p:txBody>
@@ -7847,7 +8189,7 @@
                         </a:defRPr>
                       </a:pPr>
                       <a:r>
-                        <a:t>Qué se hizo</a:t>
+                        <a:t>Tratamiento</a:t>
                       </a:r>
                     </a:p>
                   </a:txBody>
@@ -8182,7 +8524,7 @@
                         </a:defRPr>
                       </a:pPr>
                       <a:r>
-                        <a:t>es un tercio del dato y tiene comportamiento propio</a:t>
+                        <a:t>es cerca del 29 % del dato y tiene comportamiento propio</a:t>
                       </a:r>
                     </a:p>
                   </a:txBody>
@@ -8235,7 +8577,7 @@
                         </a:defRPr>
                       </a:pPr>
                       <a:r>
-                        <a:t>el -1 no es un número</a:t>
+                        <a:t>el -1 es un código de ausencia, no una cantidad de días</a:t>
                       </a:r>
                     </a:p>
                   </a:txBody>
@@ -8486,7 +8828,7 @@
               </a:defRPr>
             </a:pPr>
             <a:r>
-              <a:t>• Más de 365 días son 691 filas (1.5 %), se tratan igual bajo el mismo supuesto</a:t>
+              <a:t>• Desde 365 días la tasa vuelve a subir a 27 %, pero son 691 filas (1.5 %) y se asumen bajo el mismo umbral para no abrir un tercer caso</a:t>
             </a:r>
           </a:p>
           <a:p>
@@ -8657,7 +8999,7 @@
         <p:spPr>
           <a:xfrm>
             <a:off x="457200" y="1325880"/>
-            <a:ext cx="6766560" cy="4386567"/>
+            <a:ext cx="6766560" cy="4415928"/>
           </a:xfrm>
           <a:prstGeom prst="rect">
             <a:avLst/>
@@ -8674,7 +9016,7 @@
         </p:nvGraphicFramePr>
         <p:xfrm>
           <a:off x="7406640" y="1463040"/>
-          <a:ext cx="4480560" cy="2194560"/>
+          <a:ext cx="4480560" cy="2468880"/>
         </p:xfrm>
         <a:graphic>
           <a:graphicData uri="http://schemas.openxmlformats.org/drawingml/2006/table">
@@ -8687,7 +9029,7 @@
                 <a:gridCol w="1493520"/>
                 <a:gridCol w="1493520"/>
               </a:tblGrid>
-              <a:tr h="365760">
+              <a:tr h="352697">
                 <a:tc>
                   <a:txBody>
                     <a:bodyPr/>
@@ -8740,7 +9082,7 @@
                   <a:tcPr/>
                 </a:tc>
               </a:tr>
-              <a:tr h="365760">
+              <a:tr h="352697">
                 <a:tc>
                   <a:txBody>
                     <a:bodyPr/>
@@ -8786,14 +9128,14 @@
                         </a:defRPr>
                       </a:pPr>
                       <a:r>
-                        <a:t>recorte a 10.5 y 70.5</a:t>
+                        <a:t>recorte al borde superior 70.5</a:t>
                       </a:r>
                     </a:p>
                   </a:txBody>
                   <a:tcPr/>
                 </a:tc>
               </a:tr>
-              <a:tr h="365760">
+              <a:tr h="352697">
                 <a:tc>
                   <a:txBody>
                     <a:bodyPr/>
@@ -8846,7 +9188,7 @@
                   <a:tcPr/>
                 </a:tc>
               </a:tr>
-              <a:tr h="365760">
+              <a:tr h="352697">
                 <a:tc>
                   <a:txBody>
                     <a:bodyPr/>
@@ -8899,7 +9241,7 @@
                   <a:tcPr/>
                 </a:tc>
               </a:tr>
-              <a:tr h="365760">
+              <a:tr h="352697">
                 <a:tc>
                   <a:txBody>
                     <a:bodyPr/>
@@ -8952,7 +9294,7 @@
                   <a:tcPr/>
                 </a:tc>
               </a:tr>
-              <a:tr h="365760">
+              <a:tr h="352697">
                 <a:tc>
                   <a:txBody>
                     <a:bodyPr/>
@@ -8999,6 +9341,59 @@
                       </a:pPr>
                       <a:r>
                         <a:t>ya acotada por el umbral</a:t>
+                      </a:r>
+                    </a:p>
+                  </a:txBody>
+                  <a:tcPr/>
+                </a:tc>
+              </a:tr>
+              <a:tr h="352698">
+                <a:tc>
+                  <a:txBody>
+                    <a:bodyPr/>
+                    <a:lstStyle/>
+                    <a:p>
+                      <a:pPr>
+                        <a:defRPr sz="1300">
+                          <a:latin typeface="Calibri"/>
+                        </a:defRPr>
+                      </a:pPr>
+                      <a:r>
+                        <a:t>education, dia_anio</a:t>
+                      </a:r>
+                    </a:p>
+                  </a:txBody>
+                  <a:tcPr/>
+                </a:tc>
+                <a:tc>
+                  <a:txBody>
+                    <a:bodyPr/>
+                    <a:lstStyle/>
+                    <a:p>
+                      <a:pPr>
+                        <a:defRPr sz="1300">
+                          <a:latin typeface="Calibri"/>
+                        </a:defRPr>
+                      </a:pPr>
+                      <a:r>
+                        <a:t>sin atípicos</a:t>
+                      </a:r>
+                    </a:p>
+                  </a:txBody>
+                  <a:tcPr/>
+                </a:tc>
+                <a:tc>
+                  <a:txBody>
+                    <a:bodyPr/>
+                    <a:lstStyle/>
+                    <a:p>
+                      <a:pPr>
+                        <a:defRPr sz="1300">
+                          <a:latin typeface="Calibri"/>
+                        </a:defRPr>
+                      </a:pPr>
+                      <a:r>
+                        <a:t>sin tratamiento</a:t>
                       </a:r>
                     </a:p>
                   </a:txBody>
@@ -9017,7 +9412,7 @@
         </p:nvSpPr>
         <p:spPr>
           <a:xfrm>
-            <a:off x="7406640" y="4023360"/>
+            <a:off x="7406640" y="4206240"/>
             <a:ext cx="4480560" cy="1828800"/>
           </a:xfrm>
           <a:prstGeom prst="rect">
@@ -9053,7 +9448,7 @@
               </a:defRPr>
             </a:pPr>
             <a:r>
-              <a:t>• Los 5 255 sí son pocos y borrar filas los reduce aún más</a:t>
+              <a:t>• Los 5 255 registros de la clase sí son escasos y eliminar filas los reduciría todavía más</a:t>
             </a:r>
           </a:p>
         </p:txBody>

</xml_diff>

<commit_message>
Exposicion Bank: PDF de la presentacion y ajuste de tablas
</commit_message>
<xml_diff>
--- a/Exposicion Bank/exposicion_bank.pptx
+++ b/Exposicion Bank/exposicion_bank.pptx
@@ -4741,12 +4741,12 @@
                 <a:tableStyleId>{5C22544A-7EE6-4342-B048-85BDC9FD1C3A}</a:tableStyleId>
               </a:tblPr>
               <a:tblGrid>
-                <a:gridCol w="1874520"/>
-                <a:gridCol w="1874520"/>
-                <a:gridCol w="1874520"/>
-                <a:gridCol w="1874520"/>
-                <a:gridCol w="1874520"/>
-                <a:gridCol w="1874520"/>
+                <a:gridCol w="1463040"/>
+                <a:gridCol w="1097280"/>
+                <a:gridCol w="1828800"/>
+                <a:gridCol w="1097280"/>
+                <a:gridCol w="1097280"/>
+                <a:gridCol w="4663440"/>
               </a:tblGrid>
               <a:tr h="457200">
                 <a:tc>
@@ -5384,8 +5384,8 @@
         </p:nvSpPr>
         <p:spPr>
           <a:xfrm>
-            <a:off x="640080" y="4389120"/>
-            <a:ext cx="10972800" cy="1828800"/>
+            <a:off x="640080" y="4754880"/>
+            <a:ext cx="10972800" cy="1645920"/>
           </a:xfrm>
           <a:prstGeom prst="rect">
             <a:avLst/>
@@ -9036,7 +9036,7 @@
                     <a:lstStyle/>
                     <a:p>
                       <a:pPr>
-                        <a:defRPr sz="1300" b="1">
+                        <a:defRPr sz="1200" b="1">
                           <a:latin typeface="Calibri"/>
                         </a:defRPr>
                       </a:pPr>
@@ -9053,7 +9053,7 @@
                     <a:lstStyle/>
                     <a:p>
                       <a:pPr>
-                        <a:defRPr sz="1300" b="1">
+                        <a:defRPr sz="1200" b="1">
                           <a:latin typeface="Calibri"/>
                         </a:defRPr>
                       </a:pPr>
@@ -9070,7 +9070,7 @@
                     <a:lstStyle/>
                     <a:p>
                       <a:pPr>
-                        <a:defRPr sz="1300" b="1">
+                        <a:defRPr sz="1200" b="1">
                           <a:latin typeface="Calibri"/>
                         </a:defRPr>
                       </a:pPr>
@@ -9089,7 +9089,7 @@
                     <a:lstStyle/>
                     <a:p>
                       <a:pPr>
-                        <a:defRPr sz="1300">
+                        <a:defRPr sz="1200">
                           <a:latin typeface="Calibri"/>
                         </a:defRPr>
                       </a:pPr>
@@ -9106,7 +9106,7 @@
                     <a:lstStyle/>
                     <a:p>
                       <a:pPr>
-                        <a:defRPr sz="1300">
+                        <a:defRPr sz="1200">
                           <a:latin typeface="Calibri"/>
                         </a:defRPr>
                       </a:pPr>
@@ -9123,7 +9123,7 @@
                     <a:lstStyle/>
                     <a:p>
                       <a:pPr>
-                        <a:defRPr sz="1300">
+                        <a:defRPr sz="1200">
                           <a:latin typeface="Calibri"/>
                         </a:defRPr>
                       </a:pPr>
@@ -9142,7 +9142,7 @@
                     <a:lstStyle/>
                     <a:p>
                       <a:pPr>
-                        <a:defRPr sz="1300">
+                        <a:defRPr sz="1200">
                           <a:latin typeface="Calibri"/>
                         </a:defRPr>
                       </a:pPr>
@@ -9159,7 +9159,7 @@
                     <a:lstStyle/>
                     <a:p>
                       <a:pPr>
-                        <a:defRPr sz="1300">
+                        <a:defRPr sz="1200">
                           <a:latin typeface="Calibri"/>
                         </a:defRPr>
                       </a:pPr>
@@ -9176,7 +9176,7 @@
                     <a:lstStyle/>
                     <a:p>
                       <a:pPr>
-                        <a:defRPr sz="1300">
+                        <a:defRPr sz="1200">
                           <a:latin typeface="Calibri"/>
                         </a:defRPr>
                       </a:pPr>
@@ -9195,7 +9195,7 @@
                     <a:lstStyle/>
                     <a:p>
                       <a:pPr>
-                        <a:defRPr sz="1300">
+                        <a:defRPr sz="1200">
                           <a:latin typeface="Calibri"/>
                         </a:defRPr>
                       </a:pPr>
@@ -9212,7 +9212,7 @@
                     <a:lstStyle/>
                     <a:p>
                       <a:pPr>
-                        <a:defRPr sz="1300">
+                        <a:defRPr sz="1200">
                           <a:latin typeface="Calibri"/>
                         </a:defRPr>
                       </a:pPr>
@@ -9229,7 +9229,7 @@
                     <a:lstStyle/>
                     <a:p>
                       <a:pPr>
-                        <a:defRPr sz="1300">
+                        <a:defRPr sz="1200">
                           <a:latin typeface="Calibri"/>
                         </a:defRPr>
                       </a:pPr>
@@ -9248,7 +9248,7 @@
                     <a:lstStyle/>
                     <a:p>
                       <a:pPr>
-                        <a:defRPr sz="1300">
+                        <a:defRPr sz="1200">
                           <a:latin typeface="Calibri"/>
                         </a:defRPr>
                       </a:pPr>
@@ -9265,7 +9265,7 @@
                     <a:lstStyle/>
                     <a:p>
                       <a:pPr>
-                        <a:defRPr sz="1300">
+                        <a:defRPr sz="1200">
                           <a:latin typeface="Calibri"/>
                         </a:defRPr>
                       </a:pPr>
@@ -9282,7 +9282,7 @@
                     <a:lstStyle/>
                     <a:p>
                       <a:pPr>
-                        <a:defRPr sz="1300">
+                        <a:defRPr sz="1200">
                           <a:latin typeface="Calibri"/>
                         </a:defRPr>
                       </a:pPr>
@@ -9301,7 +9301,7 @@
                     <a:lstStyle/>
                     <a:p>
                       <a:pPr>
-                        <a:defRPr sz="1300">
+                        <a:defRPr sz="1200">
                           <a:latin typeface="Calibri"/>
                         </a:defRPr>
                       </a:pPr>
@@ -9318,7 +9318,7 @@
                     <a:lstStyle/>
                     <a:p>
                       <a:pPr>
-                        <a:defRPr sz="1300">
+                        <a:defRPr sz="1200">
                           <a:latin typeface="Calibri"/>
                         </a:defRPr>
                       </a:pPr>
@@ -9335,7 +9335,7 @@
                     <a:lstStyle/>
                     <a:p>
                       <a:pPr>
-                        <a:defRPr sz="1300">
+                        <a:defRPr sz="1200">
                           <a:latin typeface="Calibri"/>
                         </a:defRPr>
                       </a:pPr>
@@ -9354,7 +9354,7 @@
                     <a:lstStyle/>
                     <a:p>
                       <a:pPr>
-                        <a:defRPr sz="1300">
+                        <a:defRPr sz="1200">
                           <a:latin typeface="Calibri"/>
                         </a:defRPr>
                       </a:pPr>
@@ -9371,7 +9371,7 @@
                     <a:lstStyle/>
                     <a:p>
                       <a:pPr>
-                        <a:defRPr sz="1300">
+                        <a:defRPr sz="1200">
                           <a:latin typeface="Calibri"/>
                         </a:defRPr>
                       </a:pPr>
@@ -9388,7 +9388,7 @@
                     <a:lstStyle/>
                     <a:p>
                       <a:pPr>
-                        <a:defRPr sz="1300">
+                        <a:defRPr sz="1200">
                           <a:latin typeface="Calibri"/>
                         </a:defRPr>
                       </a:pPr>
@@ -9412,8 +9412,8 @@
         </p:nvSpPr>
         <p:spPr>
           <a:xfrm>
-            <a:off x="7406640" y="4206240"/>
-            <a:ext cx="4480560" cy="1828800"/>
+            <a:off x="7406640" y="4846320"/>
+            <a:ext cx="4480560" cy="1645920"/>
           </a:xfrm>
           <a:prstGeom prst="rect">
             <a:avLst/>
@@ -9430,7 +9430,7 @@
               <a:spcAft>
                 <a:spcPts val="600"/>
               </a:spcAft>
-              <a:defRPr sz="1500">
+              <a:defRPr sz="1400">
                 <a:latin typeface="Calibri"/>
               </a:defRPr>
             </a:pPr>
@@ -9443,7 +9443,7 @@
               <a:spcAft>
                 <a:spcPts val="600"/>
               </a:spcAft>
-              <a:defRPr sz="1500">
+              <a:defRPr sz="1400">
                 <a:latin typeface="Calibri"/>
               </a:defRPr>
             </a:pPr>

</xml_diff>

<commit_message>
Exposicion Bank: una sola tabla por paso, T2 solo con z score
</commit_message>
<xml_diff>
--- a/Exposicion Bank/exposicion_bank.pptx
+++ b/Exposicion Bank/exposicion_bank.pptx
@@ -3993,7 +3993,7 @@
               </a:defRPr>
             </a:pPr>
             <a:r>
-              <a:t>T2. Estandarización y normalización</a:t>
+              <a:t>T2. Estandarización</a:t>
             </a:r>
           </a:p>
           <a:p>
@@ -4006,7 +4006,7 @@
               </a:defRPr>
             </a:pPr>
             <a:r>
-              <a:t>Sobre age, balance, campaign, pdays, previous y dia_anio. Las indicadoras, contactado_antes y education se quedan como están</a:t>
+              <a:t>Z score sobre age, balance, campaign, pdays, previous y dia_anio. Las indicadoras, contactado_antes y education se quedan como están</a:t>
             </a:r>
           </a:p>
         </p:txBody>
@@ -4109,7 +4109,7 @@
               </a:defRPr>
             </a:pPr>
             <a:r>
-              <a:t>• T2z con z score, media cero y desviación uno</a:t>
+              <a:t>• Se usa z score, media cero y desviación uno</a:t>
             </a:r>
           </a:p>
           <a:p>
@@ -4122,7 +4122,7 @@
               </a:defRPr>
             </a:pPr>
             <a:r>
-              <a:t>• T2n con escalado al rango 0 a 1</a:t>
+              <a:t>• El panel derecho muestra el escalado a rango 0 a 1 solo para comparar, no se conserva</a:t>
             </a:r>
           </a:p>
           <a:p>
@@ -4149,19 +4149,6 @@
             </a:pPr>
             <a:r>
               <a:t>• previous sigue concentrada en cero, es la variable con menos información</a:t>
-            </a:r>
-          </a:p>
-          <a:p>
-            <a:pPr>
-              <a:spcAft>
-                <a:spcPts val="600"/>
-              </a:spcAft>
-              <a:defRPr sz="1500">
-                <a:latin typeface="Calibri"/>
-              </a:defRPr>
-            </a:pPr>
-            <a:r>
-              <a:t>• Se guardan las dos versiones para comparar en la herramienta</a:t>
             </a:r>
           </a:p>
         </p:txBody>
@@ -4396,7 +4383,7 @@
               </a:defRPr>
             </a:pPr>
             <a:r>
-              <a:t>• Semilla fija en los dos caminos y las mismas filas en la versión z y en la versión n</a:t>
+              <a:t>• Semilla fija en los dos caminos</a:t>
             </a:r>
           </a:p>
         </p:txBody>
@@ -4542,7 +4529,7 @@
               </a:defRPr>
             </a:pPr>
             <a:r>
-              <a:t>• Tras T2 todo es numérico, las one hot y las binarias valen 0 o 1, education va de 1 a 3 y las seis numéricas están en z score o en rango 0 a 1</a:t>
+              <a:t>• Tras T2 todo es numérico, las one hot y las binarias valen 0 o 1, education va de 1 a 3 y las seis numéricas están en z score</a:t>
             </a:r>
           </a:p>
           <a:p>
@@ -4568,7 +4555,7 @@
               </a:defRPr>
             </a:pPr>
             <a:r>
-              <a:t>• Con z score las numéricas pesan más que las indicadoras, con rango 0 a 1 quedan en la misma escala, por eso se comparan las versiones z y n</a:t>
+              <a:t>• Con z score las numéricas pesan algo más que las indicadoras en la distancia, con rango 0 a 1 quedarían en la misma escala</a:t>
             </a:r>
           </a:p>
           <a:p>
@@ -4581,7 +4568,7 @@
               </a:defRPr>
             </a:pPr>
             <a:r>
-              <a:t>• KNN sirve, pero conviene la distancia euclídea sobre la versión n, o la distancia de Manhattan, que trata cada columna por igual</a:t>
+              <a:t>• KNN sirve, y si se quiere que cada columna pese igual conviene la distancia de Manhattan</a:t>
             </a:r>
           </a:p>
           <a:p>
@@ -5072,7 +5059,7 @@
                         </a:defRPr>
                       </a:pPr>
                       <a:r>
-                        <a:t>T2z y T2n</a:t>
+                        <a:t>T2</a:t>
                       </a:r>
                     </a:p>
                   </a:txBody>
@@ -5157,7 +5144,7 @@
                         </a:defRPr>
                       </a:pPr>
                       <a:r>
-                        <a:t>one hot, binarias en 0 y 1, z score o rango 0 a 1</a:t>
+                        <a:t>one hot, binarias en 0 y 1, z score en las numéricas</a:t>
                       </a:r>
                     </a:p>
                   </a:txBody>
@@ -5176,7 +5163,7 @@
                         </a:defRPr>
                       </a:pPr>
                       <a:r>
-                        <a:t>T3_1z y T3_1n</a:t>
+                        <a:t>T3_1</a:t>
                       </a:r>
                     </a:p>
                   </a:txBody>
@@ -5280,7 +5267,7 @@
                         </a:defRPr>
                       </a:pPr>
                       <a:r>
-                        <a:t>T3_2z y T3_2n</a:t>
+                        <a:t>T3_2</a:t>
                       </a:r>
                     </a:p>
                   </a:txBody>
@@ -5618,20 +5605,7 @@
               </a:defRPr>
             </a:pPr>
             <a:r>
-              <a:t>• Comparar T2z, T3_1z y T3_2z para ver el efecto de cada balanceo sobre la sensibilidad de la clase sí</a:t>
-            </a:r>
-          </a:p>
-          <a:p>
-            <a:pPr>
-              <a:spcAft>
-                <a:spcPts val="600"/>
-              </a:spcAft>
-              <a:defRPr sz="1700">
-                <a:latin typeface="Calibri"/>
-              </a:defRPr>
-            </a:pPr>
-            <a:r>
-              <a:t>• Comparar T2z frente a T2n para evaluar la sensibilidad de cada modelo al escalado</a:t>
+              <a:t>• Comparar T2, T3_1 y T3_2 para ver el efecto de cada balanceo sobre la sensibilidad de la clase sí</a:t>
             </a:r>
           </a:p>
           <a:p>
@@ -5946,7 +5920,7 @@
               </a:defRPr>
             </a:pPr>
             <a:r>
-              <a:t>– T2 codificación, estandarización y normalización</a:t>
+              <a:t>– T2 codificación y estandarización</a:t>
             </a:r>
           </a:p>
           <a:p>
@@ -7209,7 +7183,7 @@
         <p:spPr>
           <a:xfrm>
             <a:off x="457200" y="1325880"/>
-            <a:ext cx="7863840" cy="4276727"/>
+            <a:ext cx="7863840" cy="5095685"/>
           </a:xfrm>
           <a:prstGeom prst="rect">
             <a:avLst/>

</xml_diff>